<commit_message>
docs: Atualização do Banco_Agil_Apresentacao.pptx
</commit_message>
<xml_diff>
--- a/Banco_Agil_Apresentacao.pptx
+++ b/Banco_Agil_Apresentacao.pptx
@@ -313,7 +313,7 @@
           <a:p>
             <a:fld id="{5BCAD085-E8A6-8845-BD4E-CB4CCA059FC4}" type="datetimeFigureOut">
               <a:rPr lang="en-US" smtClean="0"/>
-              <a:t>5/17/2026</a:t>
+              <a:t>5/18/2026</a:t>
             </a:fld>
             <a:endParaRPr lang="en-US"/>
           </a:p>
@@ -483,7 +483,7 @@
           <a:p>
             <a:fld id="{5BCAD085-E8A6-8845-BD4E-CB4CCA059FC4}" type="datetimeFigureOut">
               <a:rPr lang="en-US" smtClean="0"/>
-              <a:t>5/17/2026</a:t>
+              <a:t>5/18/2026</a:t>
             </a:fld>
             <a:endParaRPr lang="en-US"/>
           </a:p>
@@ -663,7 +663,7 @@
           <a:p>
             <a:fld id="{5BCAD085-E8A6-8845-BD4E-CB4CCA059FC4}" type="datetimeFigureOut">
               <a:rPr lang="en-US" smtClean="0"/>
-              <a:t>5/17/2026</a:t>
+              <a:t>5/18/2026</a:t>
             </a:fld>
             <a:endParaRPr lang="en-US"/>
           </a:p>
@@ -833,7 +833,7 @@
           <a:p>
             <a:fld id="{5BCAD085-E8A6-8845-BD4E-CB4CCA059FC4}" type="datetimeFigureOut">
               <a:rPr lang="en-US" smtClean="0"/>
-              <a:t>5/17/2026</a:t>
+              <a:t>5/18/2026</a:t>
             </a:fld>
             <a:endParaRPr lang="en-US"/>
           </a:p>
@@ -1079,7 +1079,7 @@
           <a:p>
             <a:fld id="{5BCAD085-E8A6-8845-BD4E-CB4CCA059FC4}" type="datetimeFigureOut">
               <a:rPr lang="en-US" smtClean="0"/>
-              <a:t>5/17/2026</a:t>
+              <a:t>5/18/2026</a:t>
             </a:fld>
             <a:endParaRPr lang="en-US"/>
           </a:p>
@@ -1367,7 +1367,7 @@
           <a:p>
             <a:fld id="{5BCAD085-E8A6-8845-BD4E-CB4CCA059FC4}" type="datetimeFigureOut">
               <a:rPr lang="en-US" smtClean="0"/>
-              <a:t>5/17/2026</a:t>
+              <a:t>5/18/2026</a:t>
             </a:fld>
             <a:endParaRPr lang="en-US"/>
           </a:p>
@@ -1789,7 +1789,7 @@
           <a:p>
             <a:fld id="{5BCAD085-E8A6-8845-BD4E-CB4CCA059FC4}" type="datetimeFigureOut">
               <a:rPr lang="en-US" smtClean="0"/>
-              <a:t>5/17/2026</a:t>
+              <a:t>5/18/2026</a:t>
             </a:fld>
             <a:endParaRPr lang="en-US"/>
           </a:p>
@@ -1907,7 +1907,7 @@
           <a:p>
             <a:fld id="{5BCAD085-E8A6-8845-BD4E-CB4CCA059FC4}" type="datetimeFigureOut">
               <a:rPr lang="en-US" smtClean="0"/>
-              <a:t>5/17/2026</a:t>
+              <a:t>5/18/2026</a:t>
             </a:fld>
             <a:endParaRPr lang="en-US"/>
           </a:p>
@@ -2002,7 +2002,7 @@
           <a:p>
             <a:fld id="{5BCAD085-E8A6-8845-BD4E-CB4CCA059FC4}" type="datetimeFigureOut">
               <a:rPr lang="en-US" smtClean="0"/>
-              <a:t>5/17/2026</a:t>
+              <a:t>5/18/2026</a:t>
             </a:fld>
             <a:endParaRPr lang="en-US"/>
           </a:p>
@@ -2279,7 +2279,7 @@
           <a:p>
             <a:fld id="{5BCAD085-E8A6-8845-BD4E-CB4CCA059FC4}" type="datetimeFigureOut">
               <a:rPr lang="en-US" smtClean="0"/>
-              <a:t>5/17/2026</a:t>
+              <a:t>5/18/2026</a:t>
             </a:fld>
             <a:endParaRPr lang="en-US"/>
           </a:p>
@@ -2532,7 +2532,7 @@
           <a:p>
             <a:fld id="{5BCAD085-E8A6-8845-BD4E-CB4CCA059FC4}" type="datetimeFigureOut">
               <a:rPr lang="en-US" smtClean="0"/>
-              <a:t>5/17/2026</a:t>
+              <a:t>5/18/2026</a:t>
             </a:fld>
             <a:endParaRPr lang="en-US"/>
           </a:p>
@@ -2745,7 +2745,7 @@
           <a:p>
             <a:fld id="{5BCAD085-E8A6-8845-BD4E-CB4CCA059FC4}" type="datetimeFigureOut">
               <a:rPr lang="en-US" smtClean="0"/>
-              <a:t>5/17/2026</a:t>
+              <a:t>5/18/2026</a:t>
             </a:fld>
             <a:endParaRPr lang="en-US"/>
           </a:p>
@@ -4965,15 +4965,124 @@
           <a:p>
             <a:pPr algn="l"/>
             <a:r>
-              <a:rPr sz="1200" b="0" i="0">
-                <a:solidFill>
-                  <a:srgbClr val="B0C4DE"/>
-                </a:solidFill>
-              </a:rPr>
-              <a:t>CPF + data de nascimento
-Validação matemática de CPF
-Até 3 tentativas com controle automático</a:t>
-            </a:r>
+              <a:rPr sz="1200" b="0" i="0" dirty="0">
+                <a:solidFill>
+                  <a:srgbClr val="B0C4DE"/>
+                </a:solidFill>
+              </a:rPr>
+              <a:t>CPF + data de </a:t>
+            </a:r>
+            <a:r>
+              <a:rPr sz="1200" b="0" i="0" dirty="0" err="1">
+                <a:solidFill>
+                  <a:srgbClr val="B0C4DE"/>
+                </a:solidFill>
+              </a:rPr>
+              <a:t>nascimento</a:t>
+            </a:r>
+            <a:r>
+              <a:rPr sz="1200" b="0" i="0" dirty="0">
+                <a:solidFill>
+                  <a:srgbClr val="B0C4DE"/>
+                </a:solidFill>
+              </a:rPr>
+              <a:t>
+</a:t>
+            </a:r>
+            <a:r>
+              <a:rPr sz="1200" b="0" i="0" dirty="0" err="1">
+                <a:solidFill>
+                  <a:srgbClr val="B0C4DE"/>
+                </a:solidFill>
+              </a:rPr>
+              <a:t>Validação</a:t>
+            </a:r>
+            <a:r>
+              <a:rPr sz="1200" b="0" i="0" dirty="0">
+                <a:solidFill>
+                  <a:srgbClr val="B0C4DE"/>
+                </a:solidFill>
+              </a:rPr>
+              <a:t> </a:t>
+            </a:r>
+            <a:r>
+              <a:rPr sz="1200" b="0" i="0" dirty="0" err="1">
+                <a:solidFill>
+                  <a:srgbClr val="B0C4DE"/>
+                </a:solidFill>
+              </a:rPr>
+              <a:t>matemática</a:t>
+            </a:r>
+            <a:r>
+              <a:rPr sz="1200" b="0" i="0" dirty="0">
+                <a:solidFill>
+                  <a:srgbClr val="B0C4DE"/>
+                </a:solidFill>
+              </a:rPr>
+              <a:t> de CPF
+</a:t>
+            </a:r>
+            <a:r>
+              <a:rPr sz="1200" b="0" i="0" dirty="0" err="1">
+                <a:solidFill>
+                  <a:srgbClr val="B0C4DE"/>
+                </a:solidFill>
+              </a:rPr>
+              <a:t>Até</a:t>
+            </a:r>
+            <a:r>
+              <a:rPr sz="1200" b="0" i="0" dirty="0">
+                <a:solidFill>
+                  <a:srgbClr val="B0C4DE"/>
+                </a:solidFill>
+              </a:rPr>
+              <a:t> 3 </a:t>
+            </a:r>
+            <a:r>
+              <a:rPr sz="1200" b="0" i="0" dirty="0" err="1">
+                <a:solidFill>
+                  <a:srgbClr val="B0C4DE"/>
+                </a:solidFill>
+              </a:rPr>
+              <a:t>tentativas</a:t>
+            </a:r>
+            <a:r>
+              <a:rPr sz="1200" b="0" i="0" dirty="0">
+                <a:solidFill>
+                  <a:srgbClr val="B0C4DE"/>
+                </a:solidFill>
+              </a:rPr>
+              <a:t> com </a:t>
+            </a:r>
+            <a:r>
+              <a:rPr sz="1200" b="0" i="0" dirty="0" err="1">
+                <a:solidFill>
+                  <a:srgbClr val="B0C4DE"/>
+                </a:solidFill>
+              </a:rPr>
+              <a:t>controle</a:t>
+            </a:r>
+            <a:r>
+              <a:rPr sz="1200" b="0" i="0" dirty="0">
+                <a:solidFill>
+                  <a:srgbClr val="B0C4DE"/>
+                </a:solidFill>
+              </a:rPr>
+              <a:t> </a:t>
+            </a:r>
+            <a:r>
+              <a:rPr sz="1200" b="0" i="0" dirty="0" err="1">
+                <a:solidFill>
+                  <a:srgbClr val="B0C4DE"/>
+                </a:solidFill>
+              </a:rPr>
+              <a:t>automático</a:t>
+            </a:r>
+            <a:endParaRPr sz="1200" b="0" i="0" dirty="0">
+              <a:solidFill>
+                <a:srgbClr val="B0C4DE"/>
+              </a:solidFill>
+            </a:endParaRPr>
           </a:p>
         </p:txBody>
       </p:sp>
@@ -5456,6 +5565,13 @@
   <p:clrMapOvr>
     <a:masterClrMapping/>
   </p:clrMapOvr>
+  <p:timing>
+    <p:tnLst>
+      <p:par>
+        <p:cTn id="1" dur="indefinite" restart="never" nodeType="tmRoot"/>
+      </p:par>
+    </p:tnLst>
+  </p:timing>
 </p:sld>
 </file>
 
@@ -5485,7 +5601,7 @@
         <p:spPr>
           <a:xfrm>
             <a:off x="0" y="0"/>
-            <a:ext cx="12188952" cy="6858000"/>
+            <a:ext cx="12188825" cy="6858000"/>
           </a:xfrm>
           <a:prstGeom prst="rect">
             <a:avLst/>
@@ -5516,7 +5632,7 @@
           <a:lstStyle/>
           <a:p>
             <a:pPr algn="ctr"/>
-            <a:endParaRPr/>
+            <a:endParaRPr dirty="0"/>
           </a:p>
         </p:txBody>
       </p:sp>
@@ -5644,14 +5760,14 @@
       </p:sp>
       <p:sp>
         <p:nvSpPr>
-          <p:cNvPr id="6" name="TextBox 5"/>
+          <p:cNvPr id="34" name="TextBox 5"/>
           <p:cNvSpPr txBox="1"/>
           <p:nvPr/>
         </p:nvSpPr>
         <p:spPr>
           <a:xfrm>
-            <a:off x="457200" y="1463040"/>
-            <a:ext cx="5029200" cy="365760"/>
+            <a:off x="162233" y="1417320"/>
+            <a:ext cx="6318542" cy="1246495"/>
           </a:xfrm>
           <a:prstGeom prst="rect">
             <a:avLst/>
@@ -5664,1036 +5780,177 @@
           </a:bodyPr>
           <a:lstStyle/>
           <a:p>
-            <a:pPr algn="l"/>
-            <a:r>
-              <a:rPr sz="1400" b="1" i="0">
-                <a:solidFill>
-                  <a:srgbClr val="00B4D8"/>
-                </a:solidFill>
-              </a:rPr>
-              <a:t>Grafo de Estados (LangGraph)</a:t>
-            </a:r>
-          </a:p>
-        </p:txBody>
-      </p:sp>
-      <p:sp>
-        <p:nvSpPr>
-          <p:cNvPr id="7" name="TextBox 6"/>
-          <p:cNvSpPr txBox="1"/>
-          <p:nvPr/>
-        </p:nvSpPr>
-        <p:spPr>
-          <a:xfrm>
-            <a:off x="457200" y="1920240"/>
-            <a:ext cx="5029200" cy="4389120"/>
-          </a:xfrm>
-          <a:prstGeom prst="rect">
-            <a:avLst/>
-          </a:prstGeom>
-          <a:noFill/>
-        </p:spPr>
-        <p:txBody>
-          <a:bodyPr wrap="none">
-            <a:spAutoFit/>
-          </a:bodyPr>
-          <a:lstStyle/>
-          <a:p>
-            <a:r>
-              <a:rPr sz="1100">
-                <a:solidFill>
-                  <a:srgbClr val="B0C4DE"/>
-                </a:solidFill>
-                <a:latin typeface="Courier New"/>
-              </a:rPr>
-              <a:t>  [Usuário]</a:t>
-            </a:r>
-          </a:p>
-          <a:p>
-            <a:r>
-              <a:rPr sz="1100">
-                <a:solidFill>
-                  <a:srgbClr val="B0C4DE"/>
-                </a:solidFill>
-                <a:latin typeface="Courier New"/>
-              </a:rPr>
-              <a:t>      │</a:t>
-            </a:r>
-          </a:p>
-          <a:p>
-            <a:r>
-              <a:rPr sz="1100">
-                <a:solidFill>
-                  <a:srgbClr val="B0C4DE"/>
-                </a:solidFill>
-                <a:latin typeface="Courier New"/>
-              </a:rPr>
-              <a:t>  BancoAgilSession</a:t>
-            </a:r>
-          </a:p>
-          <a:p>
-            <a:r>
-              <a:rPr sz="1100">
-                <a:solidFill>
-                  <a:srgbClr val="B0C4DE"/>
-                </a:solidFill>
-                <a:latin typeface="Courier New"/>
-              </a:rPr>
-              <a:t>  (detecção de intenção)</a:t>
-            </a:r>
-          </a:p>
-          <a:p>
-            <a:r>
-              <a:rPr sz="1100">
-                <a:solidFill>
-                  <a:srgbClr val="B0C4DE"/>
-                </a:solidFill>
-                <a:latin typeface="Courier New"/>
-              </a:rPr>
-              <a:t>      │</a:t>
-            </a:r>
-          </a:p>
-          <a:p>
-            <a:r>
-              <a:rPr sz="1100">
-                <a:solidFill>
-                  <a:srgbClr val="B0C4DE"/>
-                </a:solidFill>
-                <a:latin typeface="Courier New"/>
-              </a:rPr>
-              <a:t>  banco_graph.invoke(state)</a:t>
-            </a:r>
-          </a:p>
-          <a:p>
-            <a:r>
-              <a:rPr sz="1100">
-                <a:solidFill>
-                  <a:srgbClr val="B0C4DE"/>
-                </a:solidFill>
-                <a:latin typeface="Courier New"/>
-              </a:rPr>
-              <a:t>      │</a:t>
-            </a:r>
-          </a:p>
-          <a:p>
-            <a:r>
-              <a:rPr sz="1100">
-                <a:solidFill>
-                  <a:srgbClr val="B0C4DE"/>
-                </a:solidFill>
-                <a:latin typeface="Courier New"/>
-              </a:rPr>
-              <a:t>  router_principal</a:t>
-            </a:r>
-          </a:p>
-          <a:p>
-            <a:r>
-              <a:rPr sz="1100">
-                <a:solidFill>
-                  <a:srgbClr val="B0C4DE"/>
-                </a:solidFill>
-                <a:latin typeface="Courier New"/>
-              </a:rPr>
-              <a:t>  ┌───┴───────────────┐</a:t>
-            </a:r>
-          </a:p>
-          <a:p>
-            <a:r>
-              <a:rPr sz="1100">
-                <a:solidFill>
-                  <a:srgbClr val="B0C4DE"/>
-                </a:solidFill>
-                <a:latin typeface="Courier New"/>
-              </a:rPr>
-              <a:t>  │  Triagem   Crédito│</a:t>
-            </a:r>
-          </a:p>
-          <a:p>
-            <a:r>
-              <a:rPr sz="1100">
-                <a:solidFill>
-                  <a:srgbClr val="B0C4DE"/>
-                </a:solidFill>
-                <a:latin typeface="Courier New"/>
-              </a:rPr>
-              <a:t>  │  Entrevista Câmbio│</a:t>
-            </a:r>
-          </a:p>
-          <a:p>
-            <a:r>
-              <a:rPr sz="1100">
-                <a:solidFill>
-                  <a:srgbClr val="B0C4DE"/>
-                </a:solidFill>
-                <a:latin typeface="Courier New"/>
-              </a:rPr>
-              <a:t>  └───────────────────┘</a:t>
-            </a:r>
-          </a:p>
-          <a:p>
-            <a:r>
-              <a:rPr sz="1100">
-                <a:solidFill>
-                  <a:srgbClr val="B0C4DE"/>
-                </a:solidFill>
-                <a:latin typeface="Courier New"/>
-              </a:rPr>
-              <a:t>      │  tool_call</a:t>
-            </a:r>
-          </a:p>
-          <a:p>
-            <a:r>
-              <a:rPr sz="1100">
-                <a:solidFill>
-                  <a:srgbClr val="B0C4DE"/>
-                </a:solidFill>
-                <a:latin typeface="Courier New"/>
-              </a:rPr>
-              <a:t>  ToolNode Handler</a:t>
-            </a:r>
-          </a:p>
-          <a:p>
-            <a:r>
-              <a:rPr sz="1100">
-                <a:solidFill>
-                  <a:srgbClr val="B0C4DE"/>
-                </a:solidFill>
-                <a:latin typeface="Courier New"/>
-              </a:rPr>
-              <a:t>  (atualiza estado)</a:t>
-            </a:r>
-          </a:p>
-        </p:txBody>
-      </p:sp>
-      <p:sp>
-        <p:nvSpPr>
-          <p:cNvPr id="8" name="TextBox 7"/>
-          <p:cNvSpPr txBox="1"/>
-          <p:nvPr/>
-        </p:nvSpPr>
-        <p:spPr>
-          <a:xfrm>
-            <a:off x="5760720" y="1463040"/>
-            <a:ext cx="5943600" cy="365760"/>
-          </a:xfrm>
-          <a:prstGeom prst="rect">
-            <a:avLst/>
-          </a:prstGeom>
-          <a:noFill/>
-        </p:spPr>
-        <p:txBody>
-          <a:bodyPr wrap="square">
-            <a:spAutoFit/>
-          </a:bodyPr>
-          <a:lstStyle/>
-          <a:p>
-            <a:pPr algn="l"/>
-            <a:r>
-              <a:rPr sz="1400" b="1" i="0">
-                <a:solidFill>
-                  <a:srgbClr val="00B4D8"/>
-                </a:solidFill>
-              </a:rPr>
-              <a:t>Componentes Principais</a:t>
-            </a:r>
-          </a:p>
-        </p:txBody>
-      </p:sp>
-      <p:sp>
-        <p:nvSpPr>
-          <p:cNvPr id="9" name="Rectangle 8"/>
-          <p:cNvSpPr/>
-          <p:nvPr/>
-        </p:nvSpPr>
-        <p:spPr>
-          <a:xfrm>
-            <a:off x="5760720" y="1920240"/>
-            <a:ext cx="5943600" cy="475488"/>
-          </a:xfrm>
-          <a:prstGeom prst="rect">
-            <a:avLst/>
-          </a:prstGeom>
-          <a:solidFill>
-            <a:srgbClr val="112D4A"/>
-          </a:solidFill>
-          <a:ln>
-            <a:noFill/>
-          </a:ln>
-        </p:spPr>
-        <p:style>
-          <a:lnRef idx="1">
-            <a:schemeClr val="accent1"/>
-          </a:lnRef>
-          <a:fillRef idx="3">
-            <a:schemeClr val="accent1"/>
-          </a:fillRef>
-          <a:effectRef idx="2">
-            <a:schemeClr val="accent1"/>
-          </a:effectRef>
-          <a:fontRef idx="minor">
-            <a:schemeClr val="lt1"/>
-          </a:fontRef>
-        </p:style>
-        <p:txBody>
-          <a:bodyPr rtlCol="0" anchor="ctr"/>
-          <a:lstStyle/>
-          <a:p>
-            <a:pPr algn="ctr"/>
-            <a:endParaRPr/>
-          </a:p>
-        </p:txBody>
-      </p:sp>
-      <p:sp>
-        <p:nvSpPr>
-          <p:cNvPr id="10" name="TextBox 9"/>
-          <p:cNvSpPr txBox="1"/>
-          <p:nvPr/>
-        </p:nvSpPr>
-        <p:spPr>
-          <a:xfrm>
-            <a:off x="5943600" y="1938528"/>
-            <a:ext cx="2011680" cy="256032"/>
-          </a:xfrm>
-          <a:prstGeom prst="rect">
-            <a:avLst/>
-          </a:prstGeom>
-          <a:noFill/>
-        </p:spPr>
-        <p:txBody>
-          <a:bodyPr wrap="none">
-            <a:spAutoFit/>
-          </a:bodyPr>
-          <a:lstStyle/>
-          <a:p>
-            <a:pPr algn="l"/>
-            <a:r>
-              <a:rPr sz="1000" b="1" i="0">
-                <a:solidFill>
-                  <a:srgbClr val="00B4D8"/>
-                </a:solidFill>
-              </a:rPr>
-              <a:t>agents/graph.py</a:t>
-            </a:r>
-          </a:p>
-        </p:txBody>
-      </p:sp>
-      <p:sp>
-        <p:nvSpPr>
-          <p:cNvPr id="11" name="TextBox 10"/>
-          <p:cNvSpPr txBox="1"/>
-          <p:nvPr/>
-        </p:nvSpPr>
-        <p:spPr>
-          <a:xfrm>
-            <a:off x="8092440" y="1938528"/>
-            <a:ext cx="3474720" cy="411480"/>
-          </a:xfrm>
-          <a:prstGeom prst="rect">
-            <a:avLst/>
-          </a:prstGeom>
-          <a:noFill/>
-        </p:spPr>
-        <p:txBody>
-          <a:bodyPr wrap="square">
-            <a:spAutoFit/>
-          </a:bodyPr>
-          <a:lstStyle/>
-          <a:p>
-            <a:pPr algn="l"/>
-            <a:r>
-              <a:rPr sz="900" b="0" i="0">
-                <a:solidFill>
-                  <a:srgbClr val="B0C4DE"/>
-                </a:solidFill>
-              </a:rPr>
-              <a:t>Monta o grafo e define as transições entre nós</a:t>
-            </a:r>
-          </a:p>
-        </p:txBody>
-      </p:sp>
-      <p:sp>
-        <p:nvSpPr>
-          <p:cNvPr id="12" name="Rectangle 11"/>
-          <p:cNvSpPr/>
-          <p:nvPr/>
-        </p:nvSpPr>
-        <p:spPr>
-          <a:xfrm>
-            <a:off x="5760720" y="2459736"/>
-            <a:ext cx="5943600" cy="475488"/>
-          </a:xfrm>
-          <a:prstGeom prst="rect">
-            <a:avLst/>
-          </a:prstGeom>
-          <a:solidFill>
-            <a:srgbClr val="112D4A"/>
-          </a:solidFill>
-          <a:ln>
-            <a:noFill/>
-          </a:ln>
-        </p:spPr>
-        <p:style>
-          <a:lnRef idx="1">
-            <a:schemeClr val="accent1"/>
-          </a:lnRef>
-          <a:fillRef idx="3">
-            <a:schemeClr val="accent1"/>
-          </a:fillRef>
-          <a:effectRef idx="2">
-            <a:schemeClr val="accent1"/>
-          </a:effectRef>
-          <a:fontRef idx="minor">
-            <a:schemeClr val="lt1"/>
-          </a:fontRef>
-        </p:style>
-        <p:txBody>
-          <a:bodyPr rtlCol="0" anchor="ctr"/>
-          <a:lstStyle/>
-          <a:p>
-            <a:pPr algn="ctr"/>
-            <a:endParaRPr/>
-          </a:p>
-        </p:txBody>
-      </p:sp>
-      <p:sp>
-        <p:nvSpPr>
-          <p:cNvPr id="13" name="TextBox 12"/>
-          <p:cNvSpPr txBox="1"/>
-          <p:nvPr/>
-        </p:nvSpPr>
-        <p:spPr>
-          <a:xfrm>
-            <a:off x="5943600" y="2478024"/>
-            <a:ext cx="2011680" cy="256032"/>
-          </a:xfrm>
-          <a:prstGeom prst="rect">
-            <a:avLst/>
-          </a:prstGeom>
-          <a:noFill/>
-        </p:spPr>
-        <p:txBody>
-          <a:bodyPr wrap="none">
-            <a:spAutoFit/>
-          </a:bodyPr>
-          <a:lstStyle/>
-          <a:p>
-            <a:pPr algn="l"/>
-            <a:r>
-              <a:rPr sz="1000" b="1" i="0">
-                <a:solidFill>
-                  <a:srgbClr val="00B4D8"/>
-                </a:solidFill>
-              </a:rPr>
-              <a:t>agents/router.py</a:t>
-            </a:r>
-          </a:p>
-        </p:txBody>
-      </p:sp>
-      <p:sp>
-        <p:nvSpPr>
-          <p:cNvPr id="14" name="TextBox 13"/>
-          <p:cNvSpPr txBox="1"/>
-          <p:nvPr/>
-        </p:nvSpPr>
-        <p:spPr>
-          <a:xfrm>
-            <a:off x="8092440" y="2478024"/>
-            <a:ext cx="3474720" cy="411480"/>
-          </a:xfrm>
-          <a:prstGeom prst="rect">
-            <a:avLst/>
-          </a:prstGeom>
-          <a:noFill/>
-        </p:spPr>
-        <p:txBody>
-          <a:bodyPr wrap="square">
-            <a:spAutoFit/>
-          </a:bodyPr>
-          <a:lstStyle/>
-          <a:p>
-            <a:pPr algn="l"/>
-            <a:r>
-              <a:rPr sz="900" b="0" i="0">
-                <a:solidFill>
-                  <a:srgbClr val="B0C4DE"/>
-                </a:solidFill>
-              </a:rPr>
-              <a:t>Roteamento condicional e execução de tools</a:t>
-            </a:r>
-          </a:p>
-        </p:txBody>
-      </p:sp>
-      <p:sp>
-        <p:nvSpPr>
-          <p:cNvPr id="15" name="Rectangle 14"/>
-          <p:cNvSpPr/>
-          <p:nvPr/>
-        </p:nvSpPr>
-        <p:spPr>
-          <a:xfrm>
-            <a:off x="5760720" y="2999232"/>
-            <a:ext cx="5943600" cy="475488"/>
-          </a:xfrm>
-          <a:prstGeom prst="rect">
-            <a:avLst/>
-          </a:prstGeom>
-          <a:solidFill>
-            <a:srgbClr val="112D4A"/>
-          </a:solidFill>
-          <a:ln>
-            <a:noFill/>
-          </a:ln>
-        </p:spPr>
-        <p:style>
-          <a:lnRef idx="1">
-            <a:schemeClr val="accent1"/>
-          </a:lnRef>
-          <a:fillRef idx="3">
-            <a:schemeClr val="accent1"/>
-          </a:fillRef>
-          <a:effectRef idx="2">
-            <a:schemeClr val="accent1"/>
-          </a:effectRef>
-          <a:fontRef idx="minor">
-            <a:schemeClr val="lt1"/>
-          </a:fontRef>
-        </p:style>
-        <p:txBody>
-          <a:bodyPr rtlCol="0" anchor="ctr"/>
-          <a:lstStyle/>
-          <a:p>
-            <a:pPr algn="ctr"/>
-            <a:endParaRPr/>
-          </a:p>
-        </p:txBody>
-      </p:sp>
-      <p:sp>
-        <p:nvSpPr>
-          <p:cNvPr id="16" name="TextBox 15"/>
-          <p:cNvSpPr txBox="1"/>
-          <p:nvPr/>
-        </p:nvSpPr>
-        <p:spPr>
-          <a:xfrm>
-            <a:off x="5943600" y="3017520"/>
-            <a:ext cx="2011680" cy="256032"/>
-          </a:xfrm>
-          <a:prstGeom prst="rect">
-            <a:avLst/>
-          </a:prstGeom>
-          <a:noFill/>
-        </p:spPr>
-        <p:txBody>
-          <a:bodyPr wrap="none">
-            <a:spAutoFit/>
-          </a:bodyPr>
-          <a:lstStyle/>
-          <a:p>
-            <a:pPr algn="l"/>
-            <a:r>
-              <a:rPr sz="1000" b="1" i="0">
-                <a:solidFill>
-                  <a:srgbClr val="00B4D8"/>
-                </a:solidFill>
-              </a:rPr>
-              <a:t>agents/common.py</a:t>
-            </a:r>
-          </a:p>
-        </p:txBody>
-      </p:sp>
-      <p:sp>
-        <p:nvSpPr>
-          <p:cNvPr id="17" name="TextBox 16"/>
-          <p:cNvSpPr txBox="1"/>
-          <p:nvPr/>
-        </p:nvSpPr>
-        <p:spPr>
-          <a:xfrm>
-            <a:off x="8092440" y="3017520"/>
-            <a:ext cx="3474720" cy="411480"/>
-          </a:xfrm>
-          <a:prstGeom prst="rect">
-            <a:avLst/>
-          </a:prstGeom>
-          <a:noFill/>
-        </p:spPr>
-        <p:txBody>
-          <a:bodyPr wrap="square">
-            <a:spAutoFit/>
-          </a:bodyPr>
-          <a:lstStyle/>
-          <a:p>
-            <a:pPr algn="l"/>
-            <a:r>
-              <a:rPr sz="900" b="0" i="0">
-                <a:solidFill>
-                  <a:srgbClr val="B0C4DE"/>
-                </a:solidFill>
-              </a:rPr>
-              <a:t>Fabrica o LLM e injeta contexto dinâmico</a:t>
-            </a:r>
-          </a:p>
-        </p:txBody>
-      </p:sp>
-      <p:sp>
-        <p:nvSpPr>
-          <p:cNvPr id="18" name="Rectangle 17"/>
-          <p:cNvSpPr/>
-          <p:nvPr/>
-        </p:nvSpPr>
-        <p:spPr>
-          <a:xfrm>
-            <a:off x="5760720" y="3538728"/>
-            <a:ext cx="5943600" cy="475488"/>
-          </a:xfrm>
-          <a:prstGeom prst="rect">
-            <a:avLst/>
-          </a:prstGeom>
-          <a:solidFill>
-            <a:srgbClr val="112D4A"/>
-          </a:solidFill>
-          <a:ln>
-            <a:noFill/>
-          </a:ln>
-        </p:spPr>
-        <p:style>
-          <a:lnRef idx="1">
-            <a:schemeClr val="accent1"/>
-          </a:lnRef>
-          <a:fillRef idx="3">
-            <a:schemeClr val="accent1"/>
-          </a:fillRef>
-          <a:effectRef idx="2">
-            <a:schemeClr val="accent1"/>
-          </a:effectRef>
-          <a:fontRef idx="minor">
-            <a:schemeClr val="lt1"/>
-          </a:fontRef>
-        </p:style>
-        <p:txBody>
-          <a:bodyPr rtlCol="0" anchor="ctr"/>
-          <a:lstStyle/>
-          <a:p>
-            <a:pPr algn="ctr"/>
-            <a:endParaRPr/>
-          </a:p>
-        </p:txBody>
-      </p:sp>
-      <p:sp>
-        <p:nvSpPr>
-          <p:cNvPr id="19" name="TextBox 18"/>
-          <p:cNvSpPr txBox="1"/>
-          <p:nvPr/>
-        </p:nvSpPr>
-        <p:spPr>
-          <a:xfrm>
-            <a:off x="5943600" y="3557016"/>
-            <a:ext cx="2011680" cy="256032"/>
-          </a:xfrm>
-          <a:prstGeom prst="rect">
-            <a:avLst/>
-          </a:prstGeom>
-          <a:noFill/>
-        </p:spPr>
-        <p:txBody>
-          <a:bodyPr wrap="none">
-            <a:spAutoFit/>
-          </a:bodyPr>
-          <a:lstStyle/>
-          <a:p>
-            <a:pPr algn="l"/>
-            <a:r>
-              <a:rPr sz="1000" b="1" i="0">
-                <a:solidFill>
-                  <a:srgbClr val="00B4D8"/>
-                </a:solidFill>
-              </a:rPr>
-              <a:t>agents/prompts.py</a:t>
-            </a:r>
-          </a:p>
-        </p:txBody>
-      </p:sp>
-      <p:sp>
-        <p:nvSpPr>
-          <p:cNvPr id="20" name="TextBox 19"/>
-          <p:cNvSpPr txBox="1"/>
-          <p:nvPr/>
-        </p:nvSpPr>
-        <p:spPr>
-          <a:xfrm>
-            <a:off x="8092440" y="3557016"/>
-            <a:ext cx="3474720" cy="411480"/>
-          </a:xfrm>
-          <a:prstGeom prst="rect">
-            <a:avLst/>
-          </a:prstGeom>
-          <a:noFill/>
-        </p:spPr>
-        <p:txBody>
-          <a:bodyPr wrap="square">
-            <a:spAutoFit/>
-          </a:bodyPr>
-          <a:lstStyle/>
-          <a:p>
-            <a:pPr algn="l"/>
-            <a:r>
-              <a:rPr sz="900" b="0" i="0">
-                <a:solidFill>
-                  <a:srgbClr val="B0C4DE"/>
-                </a:solidFill>
-              </a:rPr>
-              <a:t>Prompts de cada agente em arquivo único</a:t>
-            </a:r>
-          </a:p>
-        </p:txBody>
-      </p:sp>
-      <p:sp>
-        <p:nvSpPr>
-          <p:cNvPr id="21" name="Rectangle 20"/>
-          <p:cNvSpPr/>
-          <p:nvPr/>
-        </p:nvSpPr>
-        <p:spPr>
-          <a:xfrm>
-            <a:off x="5760720" y="4078224"/>
-            <a:ext cx="5943600" cy="475488"/>
-          </a:xfrm>
-          <a:prstGeom prst="rect">
-            <a:avLst/>
-          </a:prstGeom>
-          <a:solidFill>
-            <a:srgbClr val="112D4A"/>
-          </a:solidFill>
-          <a:ln>
-            <a:noFill/>
-          </a:ln>
-        </p:spPr>
-        <p:style>
-          <a:lnRef idx="1">
-            <a:schemeClr val="accent1"/>
-          </a:lnRef>
-          <a:fillRef idx="3">
-            <a:schemeClr val="accent1"/>
-          </a:fillRef>
-          <a:effectRef idx="2">
-            <a:schemeClr val="accent1"/>
-          </a:effectRef>
-          <a:fontRef idx="minor">
-            <a:schemeClr val="lt1"/>
-          </a:fontRef>
-        </p:style>
-        <p:txBody>
-          <a:bodyPr rtlCol="0" anchor="ctr"/>
-          <a:lstStyle/>
-          <a:p>
-            <a:pPr algn="ctr"/>
-            <a:endParaRPr/>
-          </a:p>
-        </p:txBody>
-      </p:sp>
-      <p:sp>
-        <p:nvSpPr>
-          <p:cNvPr id="22" name="TextBox 21"/>
-          <p:cNvSpPr txBox="1"/>
-          <p:nvPr/>
-        </p:nvSpPr>
-        <p:spPr>
-          <a:xfrm>
-            <a:off x="5943600" y="4096511"/>
-            <a:ext cx="2011680" cy="256032"/>
-          </a:xfrm>
-          <a:prstGeom prst="rect">
-            <a:avLst/>
-          </a:prstGeom>
-          <a:noFill/>
-        </p:spPr>
-        <p:txBody>
-          <a:bodyPr wrap="none">
-            <a:spAutoFit/>
-          </a:bodyPr>
-          <a:lstStyle/>
-          <a:p>
-            <a:pPr algn="l"/>
-            <a:r>
-              <a:rPr sz="1000" b="1" i="0">
-                <a:solidFill>
-                  <a:srgbClr val="00B4D8"/>
-                </a:solidFill>
-              </a:rPr>
-              <a:t>tools/ferramentas.py</a:t>
-            </a:r>
-          </a:p>
-        </p:txBody>
-      </p:sp>
-      <p:sp>
-        <p:nvSpPr>
-          <p:cNvPr id="23" name="TextBox 22"/>
-          <p:cNvSpPr txBox="1"/>
-          <p:nvPr/>
-        </p:nvSpPr>
-        <p:spPr>
-          <a:xfrm>
-            <a:off x="8092440" y="4096511"/>
-            <a:ext cx="3474720" cy="411480"/>
-          </a:xfrm>
-          <a:prstGeom prst="rect">
-            <a:avLst/>
-          </a:prstGeom>
-          <a:noFill/>
-        </p:spPr>
-        <p:txBody>
-          <a:bodyPr wrap="square">
-            <a:spAutoFit/>
-          </a:bodyPr>
-          <a:lstStyle/>
-          <a:p>
-            <a:pPr algn="l"/>
-            <a:r>
-              <a:rPr sz="900" b="0" i="0">
-                <a:solidFill>
-                  <a:srgbClr val="B0C4DE"/>
-                </a:solidFill>
-              </a:rPr>
-              <a:t>6 ferramentas @tool (validar_cpf, autenticar, crédito, score, câmbio, encerrar)</a:t>
-            </a:r>
-          </a:p>
-        </p:txBody>
-      </p:sp>
-      <p:sp>
-        <p:nvSpPr>
-          <p:cNvPr id="24" name="Rectangle 23"/>
-          <p:cNvSpPr/>
-          <p:nvPr/>
-        </p:nvSpPr>
-        <p:spPr>
-          <a:xfrm>
-            <a:off x="5760720" y="4617720"/>
-            <a:ext cx="5943600" cy="475488"/>
-          </a:xfrm>
-          <a:prstGeom prst="rect">
-            <a:avLst/>
-          </a:prstGeom>
-          <a:solidFill>
-            <a:srgbClr val="112D4A"/>
-          </a:solidFill>
-          <a:ln>
-            <a:noFill/>
-          </a:ln>
-        </p:spPr>
-        <p:style>
-          <a:lnRef idx="1">
-            <a:schemeClr val="accent1"/>
-          </a:lnRef>
-          <a:fillRef idx="3">
-            <a:schemeClr val="accent1"/>
-          </a:fillRef>
-          <a:effectRef idx="2">
-            <a:schemeClr val="accent1"/>
-          </a:effectRef>
-          <a:fontRef idx="minor">
-            <a:schemeClr val="lt1"/>
-          </a:fontRef>
-        </p:style>
-        <p:txBody>
-          <a:bodyPr rtlCol="0" anchor="ctr"/>
-          <a:lstStyle/>
-          <a:p>
-            <a:pPr algn="ctr"/>
-            <a:endParaRPr/>
-          </a:p>
-        </p:txBody>
-      </p:sp>
-      <p:sp>
-        <p:nvSpPr>
-          <p:cNvPr id="25" name="TextBox 24"/>
-          <p:cNvSpPr txBox="1"/>
-          <p:nvPr/>
-        </p:nvSpPr>
-        <p:spPr>
-          <a:xfrm>
-            <a:off x="5943600" y="4636007"/>
-            <a:ext cx="2011680" cy="256032"/>
-          </a:xfrm>
-          <a:prstGeom prst="rect">
-            <a:avLst/>
-          </a:prstGeom>
-          <a:noFill/>
-        </p:spPr>
-        <p:txBody>
-          <a:bodyPr wrap="none">
-            <a:spAutoFit/>
-          </a:bodyPr>
-          <a:lstStyle/>
-          <a:p>
-            <a:pPr algn="l"/>
-            <a:r>
-              <a:rPr sz="1000" b="1" i="0">
-                <a:solidFill>
-                  <a:srgbClr val="00B4D8"/>
-                </a:solidFill>
-              </a:rPr>
-              <a:t>utils/state.py</a:t>
-            </a:r>
-          </a:p>
-        </p:txBody>
-      </p:sp>
-      <p:sp>
-        <p:nvSpPr>
-          <p:cNvPr id="26" name="TextBox 25"/>
-          <p:cNvSpPr txBox="1"/>
-          <p:nvPr/>
-        </p:nvSpPr>
-        <p:spPr>
-          <a:xfrm>
-            <a:off x="8092440" y="4636007"/>
-            <a:ext cx="3611880" cy="369332"/>
-          </a:xfrm>
-          <a:prstGeom prst="rect">
-            <a:avLst/>
-          </a:prstGeom>
-          <a:noFill/>
-        </p:spPr>
-        <p:txBody>
-          <a:bodyPr wrap="square">
-            <a:spAutoFit/>
-          </a:bodyPr>
-          <a:lstStyle/>
-          <a:p>
-            <a:r>
-              <a:rPr lang="pt-BR" sz="900" dirty="0" smtClean="0">
-                <a:solidFill>
-                  <a:srgbClr val="B0C4DE"/>
-                </a:solidFill>
-              </a:rPr>
-              <a:t>Define </a:t>
-            </a:r>
-            <a:r>
-              <a:rPr lang="pt-BR" sz="900" dirty="0">
-                <a:solidFill>
-                  <a:srgbClr val="B0C4DE"/>
-                </a:solidFill>
-              </a:rPr>
-              <a:t>o estado compartilhado entre todos os agentes do sistema (</a:t>
-            </a:r>
-            <a:r>
-              <a:rPr lang="pt-BR" sz="900" dirty="0" smtClean="0">
-                <a:solidFill>
-                  <a:srgbClr val="B0C4DE"/>
-                </a:solidFill>
-              </a:rPr>
-              <a:t>é </a:t>
-            </a:r>
-            <a:r>
-              <a:rPr lang="pt-BR" sz="900" dirty="0">
-                <a:solidFill>
-                  <a:srgbClr val="B0C4DE"/>
-                </a:solidFill>
-              </a:rPr>
-              <a:t>a "memória central" que persiste durante toda a sessão de </a:t>
-            </a:r>
-            <a:r>
-              <a:rPr lang="pt-BR" sz="900" dirty="0" smtClean="0">
-                <a:solidFill>
-                  <a:srgbClr val="B0C4DE"/>
-                </a:solidFill>
-              </a:rPr>
-              <a:t>atendimento)</a:t>
-            </a:r>
-            <a:endParaRPr sz="900" b="0" i="0" dirty="0">
+            <a:r>
+              <a:rPr lang="pt-BR" sz="1500" b="1" dirty="0">
+                <a:solidFill>
+                  <a:srgbClr val="B0C4DE"/>
+                </a:solidFill>
+              </a:rPr>
+              <a:t>Visão </a:t>
+            </a:r>
+            <a:r>
+              <a:rPr lang="pt-BR" sz="1500" b="1" dirty="0" smtClean="0">
+                <a:solidFill>
+                  <a:srgbClr val="B0C4DE"/>
+                </a:solidFill>
+              </a:rPr>
+              <a:t>Geral </a:t>
+            </a:r>
+            <a:r>
+              <a:rPr lang="pt-BR" sz="1500" b="1" dirty="0">
+                <a:solidFill>
+                  <a:srgbClr val="B0C4DE"/>
+                </a:solidFill>
+              </a:rPr>
+              <a:t>do G</a:t>
+            </a:r>
+            <a:r>
+              <a:rPr lang="pt-BR" sz="1500" b="1" dirty="0" smtClean="0">
+                <a:solidFill>
+                  <a:srgbClr val="B0C4DE"/>
+                </a:solidFill>
+              </a:rPr>
+              <a:t>rafo</a:t>
+            </a:r>
+          </a:p>
+          <a:p>
+            <a:endParaRPr lang="pt-BR" sz="1500" b="1" dirty="0">
               <a:solidFill>
                 <a:srgbClr val="B0C4DE"/>
               </a:solidFill>
             </a:endParaRPr>
           </a:p>
-        </p:txBody>
-      </p:sp>
-      <p:sp>
-        <p:nvSpPr>
-          <p:cNvPr id="27" name="Rectangle 26"/>
-          <p:cNvSpPr/>
-          <p:nvPr/>
-        </p:nvSpPr>
-        <p:spPr>
-          <a:xfrm>
-            <a:off x="5760720" y="5157216"/>
-            <a:ext cx="5943600" cy="475488"/>
-          </a:xfrm>
-          <a:prstGeom prst="rect">
-            <a:avLst/>
-          </a:prstGeom>
-          <a:solidFill>
-            <a:srgbClr val="112D4A"/>
-          </a:solidFill>
-          <a:ln>
-            <a:noFill/>
-          </a:ln>
-        </p:spPr>
-        <p:style>
-          <a:lnRef idx="1">
-            <a:schemeClr val="accent1"/>
-          </a:lnRef>
-          <a:fillRef idx="3">
-            <a:schemeClr val="accent1"/>
-          </a:fillRef>
-          <a:effectRef idx="2">
-            <a:schemeClr val="accent1"/>
-          </a:effectRef>
-          <a:fontRef idx="minor">
-            <a:schemeClr val="lt1"/>
-          </a:fontRef>
-        </p:style>
-        <p:txBody>
-          <a:bodyPr rtlCol="0" anchor="ctr"/>
-          <a:lstStyle/>
-          <a:p>
-            <a:pPr algn="ctr"/>
-            <a:endParaRPr/>
-          </a:p>
-        </p:txBody>
-      </p:sp>
-      <p:sp>
-        <p:nvSpPr>
-          <p:cNvPr id="28" name="TextBox 27"/>
+          <a:p>
+            <a:r>
+              <a:rPr lang="pt-BR" sz="1500" dirty="0">
+                <a:solidFill>
+                  <a:srgbClr val="B0C4DE"/>
+                </a:solidFill>
+              </a:rPr>
+              <a:t>O grafo </a:t>
+            </a:r>
+            <a:r>
+              <a:rPr lang="pt-BR" sz="1500" dirty="0" err="1">
+                <a:solidFill>
+                  <a:srgbClr val="B0C4DE"/>
+                </a:solidFill>
+              </a:rPr>
+              <a:t>LangGraph</a:t>
+            </a:r>
+            <a:r>
+              <a:rPr lang="pt-BR" sz="1500" dirty="0">
+                <a:solidFill>
+                  <a:srgbClr val="B0C4DE"/>
+                </a:solidFill>
+              </a:rPr>
+              <a:t> utiliza entrada condicional via START: a cada invocação, o roteador verifica o campo </a:t>
+            </a:r>
+            <a:r>
+              <a:rPr lang="pt-BR" sz="1500" dirty="0" err="1">
+                <a:solidFill>
+                  <a:srgbClr val="B0C4DE"/>
+                </a:solidFill>
+              </a:rPr>
+              <a:t>agente_atual</a:t>
+            </a:r>
+            <a:r>
+              <a:rPr lang="pt-BR" sz="1500" dirty="0">
+                <a:solidFill>
+                  <a:srgbClr val="B0C4DE"/>
+                </a:solidFill>
+              </a:rPr>
+              <a:t> do estado e direciona para o nó correto (</a:t>
+            </a:r>
+            <a:r>
+              <a:rPr lang="pt-BR" sz="1500" dirty="0" smtClean="0">
+                <a:solidFill>
+                  <a:srgbClr val="B0C4DE"/>
+                </a:solidFill>
+              </a:rPr>
+              <a:t>sem </a:t>
+            </a:r>
+            <a:r>
+              <a:rPr lang="pt-BR" sz="1500" dirty="0">
+                <a:solidFill>
+                  <a:srgbClr val="B0C4DE"/>
+                </a:solidFill>
+              </a:rPr>
+              <a:t>passar pela triagem em toda </a:t>
+            </a:r>
+            <a:r>
+              <a:rPr lang="pt-BR" sz="1500" dirty="0" smtClean="0">
+                <a:solidFill>
+                  <a:srgbClr val="B0C4DE"/>
+                </a:solidFill>
+              </a:rPr>
+              <a:t>mensagem)</a:t>
+            </a:r>
+            <a:endParaRPr sz="1500" b="0" i="0" dirty="0">
+              <a:solidFill>
+                <a:srgbClr val="B0C4DE"/>
+              </a:solidFill>
+            </a:endParaRPr>
+          </a:p>
+        </p:txBody>
+      </p:sp>
+      <p:pic>
+        <p:nvPicPr>
+          <p:cNvPr id="36" name="Imagem 35"/>
+          <p:cNvPicPr>
+            <a:picLocks noChangeAspect="1"/>
+          </p:cNvPicPr>
+          <p:nvPr/>
+        </p:nvPicPr>
+        <p:blipFill>
+          <a:blip r:embed="rId2"/>
+          <a:stretch>
+            <a:fillRect/>
+          </a:stretch>
+        </p:blipFill>
+        <p:spPr>
+          <a:xfrm>
+            <a:off x="342047" y="2924388"/>
+            <a:ext cx="6032095" cy="3446911"/>
+          </a:xfrm>
+          <a:prstGeom prst="rect">
+            <a:avLst/>
+          </a:prstGeom>
+        </p:spPr>
+      </p:pic>
+      <p:pic>
+        <p:nvPicPr>
+          <p:cNvPr id="37" name="Imagem 36"/>
+          <p:cNvPicPr>
+            <a:picLocks noChangeAspect="1"/>
+          </p:cNvPicPr>
+          <p:nvPr/>
+        </p:nvPicPr>
+        <p:blipFill>
+          <a:blip r:embed="rId3"/>
+          <a:stretch>
+            <a:fillRect/>
+          </a:stretch>
+        </p:blipFill>
+        <p:spPr>
+          <a:xfrm>
+            <a:off x="6725265" y="1814489"/>
+            <a:ext cx="5337057" cy="4933675"/>
+          </a:xfrm>
+          <a:prstGeom prst="rect">
+            <a:avLst/>
+          </a:prstGeom>
+        </p:spPr>
+      </p:pic>
+      <p:sp>
+        <p:nvSpPr>
+          <p:cNvPr id="38" name="TextBox 5"/>
           <p:cNvSpPr txBox="1"/>
           <p:nvPr/>
         </p:nvSpPr>
         <p:spPr>
           <a:xfrm>
-            <a:off x="5943600" y="5175504"/>
-            <a:ext cx="2011680" cy="256032"/>
-          </a:xfrm>
-          <a:prstGeom prst="rect">
-            <a:avLst/>
-          </a:prstGeom>
-          <a:noFill/>
-        </p:spPr>
-        <p:txBody>
-          <a:bodyPr wrap="none">
-            <a:spAutoFit/>
-          </a:bodyPr>
-          <a:lstStyle/>
-          <a:p>
-            <a:pPr algn="l"/>
-            <a:r>
-              <a:rPr sz="1000" b="1" i="0">
-                <a:solidFill>
-                  <a:srgbClr val="00B4D8"/>
-                </a:solidFill>
-              </a:rPr>
-              <a:t>utils/session.py</a:t>
-            </a:r>
-          </a:p>
-        </p:txBody>
-      </p:sp>
-      <p:sp>
-        <p:nvSpPr>
-          <p:cNvPr id="29" name="TextBox 28"/>
-          <p:cNvSpPr txBox="1"/>
-          <p:nvPr/>
-        </p:nvSpPr>
-        <p:spPr>
-          <a:xfrm>
-            <a:off x="8092440" y="5175504"/>
-            <a:ext cx="3474720" cy="411480"/>
+            <a:off x="6636774" y="1390093"/>
+            <a:ext cx="5102942" cy="323165"/>
           </a:xfrm>
           <a:prstGeom prst="rect">
             <a:avLst/>
@@ -6706,127 +5963,19 @@
           </a:bodyPr>
           <a:lstStyle/>
           <a:p>
-            <a:pPr algn="l"/>
-            <a:r>
-              <a:rPr sz="900" b="0" i="0">
-                <a:solidFill>
-                  <a:srgbClr val="B0C4DE"/>
-                </a:solidFill>
-              </a:rPr>
-              <a:t>Sessão: detecta intenção e gerencia ciclo de vida</a:t>
-            </a:r>
-          </a:p>
-        </p:txBody>
-      </p:sp>
-      <p:sp>
-        <p:nvSpPr>
-          <p:cNvPr id="30" name="Rectangle 29"/>
-          <p:cNvSpPr/>
-          <p:nvPr/>
-        </p:nvSpPr>
-        <p:spPr>
-          <a:xfrm>
-            <a:off x="5760720" y="5696712"/>
-            <a:ext cx="5943600" cy="475488"/>
-          </a:xfrm>
-          <a:prstGeom prst="rect">
-            <a:avLst/>
-          </a:prstGeom>
-          <a:solidFill>
-            <a:srgbClr val="112D4A"/>
-          </a:solidFill>
-          <a:ln>
-            <a:noFill/>
-          </a:ln>
-        </p:spPr>
-        <p:style>
-          <a:lnRef idx="1">
-            <a:schemeClr val="accent1"/>
-          </a:lnRef>
-          <a:fillRef idx="3">
-            <a:schemeClr val="accent1"/>
-          </a:fillRef>
-          <a:effectRef idx="2">
-            <a:schemeClr val="accent1"/>
-          </a:effectRef>
-          <a:fontRef idx="minor">
-            <a:schemeClr val="lt1"/>
-          </a:fontRef>
-        </p:style>
-        <p:txBody>
-          <a:bodyPr rtlCol="0" anchor="ctr"/>
-          <a:lstStyle/>
-          <a:p>
-            <a:pPr algn="ctr"/>
-            <a:endParaRPr/>
-          </a:p>
-        </p:txBody>
-      </p:sp>
-      <p:sp>
-        <p:nvSpPr>
-          <p:cNvPr id="31" name="TextBox 30"/>
-          <p:cNvSpPr txBox="1"/>
-          <p:nvPr/>
-        </p:nvSpPr>
-        <p:spPr>
-          <a:xfrm>
-            <a:off x="5943600" y="5715000"/>
-            <a:ext cx="2011680" cy="256032"/>
-          </a:xfrm>
-          <a:prstGeom prst="rect">
-            <a:avLst/>
-          </a:prstGeom>
-          <a:noFill/>
-        </p:spPr>
-        <p:txBody>
-          <a:bodyPr wrap="none">
-            <a:spAutoFit/>
-          </a:bodyPr>
-          <a:lstStyle/>
-          <a:p>
-            <a:pPr algn="l"/>
-            <a:r>
-              <a:rPr sz="1000" b="1" i="0">
-                <a:solidFill>
-                  <a:srgbClr val="00B4D8"/>
-                </a:solidFill>
-              </a:rPr>
-              <a:t>app.py</a:t>
-            </a:r>
-          </a:p>
-        </p:txBody>
-      </p:sp>
-      <p:sp>
-        <p:nvSpPr>
-          <p:cNvPr id="32" name="TextBox 31"/>
-          <p:cNvSpPr txBox="1"/>
-          <p:nvPr/>
-        </p:nvSpPr>
-        <p:spPr>
-          <a:xfrm>
-            <a:off x="8092440" y="5715000"/>
-            <a:ext cx="3474720" cy="411480"/>
-          </a:xfrm>
-          <a:prstGeom prst="rect">
-            <a:avLst/>
-          </a:prstGeom>
-          <a:noFill/>
-        </p:spPr>
-        <p:txBody>
-          <a:bodyPr wrap="square">
-            <a:spAutoFit/>
-          </a:bodyPr>
-          <a:lstStyle/>
-          <a:p>
-            <a:pPr algn="l"/>
-            <a:r>
-              <a:rPr sz="900" b="0" i="0">
-                <a:solidFill>
-                  <a:srgbClr val="B0C4DE"/>
-                </a:solidFill>
-              </a:rPr>
-              <a:t>Interface Streamlit (tema bancário escuro)</a:t>
-            </a:r>
+            <a:r>
+              <a:rPr lang="pt-BR" sz="1500" b="1" dirty="0" smtClean="0">
+                <a:solidFill>
+                  <a:srgbClr val="B0C4DE"/>
+                </a:solidFill>
+              </a:rPr>
+              <a:t>Estrutura dos Arquivos</a:t>
+            </a:r>
+            <a:endParaRPr sz="1500" b="0" i="0" dirty="0">
+              <a:solidFill>
+                <a:srgbClr val="B0C4DE"/>
+              </a:solidFill>
+            </a:endParaRPr>
           </a:p>
         </p:txBody>
       </p:sp>
@@ -6835,6 +5984,13 @@
   <p:clrMapOvr>
     <a:masterClrMapping/>
   </p:clrMapOvr>
+  <p:timing>
+    <p:tnLst>
+      <p:par>
+        <p:cTn id="1" dur="indefinite" restart="never" nodeType="tmRoot"/>
+      </p:par>
+    </p:tnLst>
+  </p:timing>
 </p:sld>
 </file>
 
@@ -7387,7 +6543,7 @@
         <p:spPr>
           <a:xfrm>
             <a:off x="6419088" y="2011680"/>
-            <a:ext cx="5394960" cy="1783080"/>
+            <a:ext cx="5394960" cy="1041311"/>
           </a:xfrm>
           <a:prstGeom prst="rect">
             <a:avLst/>
@@ -7406,13 +6562,74 @@
               </a:spcBef>
             </a:pPr>
             <a:r>
-              <a:rPr sz="1100">
-                <a:solidFill>
-                  <a:srgbClr val="B0C4DE"/>
-                </a:solidFill>
-              </a:rPr>
-              <a:t>▸  Consulta o limite atual do cliente</a:t>
-            </a:r>
+              <a:rPr sz="1100" dirty="0">
+                <a:solidFill>
+                  <a:srgbClr val="B0C4DE"/>
+                </a:solidFill>
+              </a:rPr>
+              <a:t>▸  </a:t>
+            </a:r>
+            <a:r>
+              <a:rPr sz="1100" dirty="0" err="1">
+                <a:solidFill>
+                  <a:srgbClr val="B0C4DE"/>
+                </a:solidFill>
+              </a:rPr>
+              <a:t>Consulta</a:t>
+            </a:r>
+            <a:r>
+              <a:rPr sz="1100" dirty="0">
+                <a:solidFill>
+                  <a:srgbClr val="B0C4DE"/>
+                </a:solidFill>
+              </a:rPr>
+              <a:t> o </a:t>
+            </a:r>
+            <a:r>
+              <a:rPr sz="1100" dirty="0" err="1">
+                <a:solidFill>
+                  <a:srgbClr val="B0C4DE"/>
+                </a:solidFill>
+              </a:rPr>
+              <a:t>limite</a:t>
+            </a:r>
+            <a:r>
+              <a:rPr sz="1100" dirty="0">
+                <a:solidFill>
+                  <a:srgbClr val="B0C4DE"/>
+                </a:solidFill>
+              </a:rPr>
+              <a:t> </a:t>
+            </a:r>
+            <a:r>
+              <a:rPr sz="1100" dirty="0" err="1">
+                <a:solidFill>
+                  <a:srgbClr val="B0C4DE"/>
+                </a:solidFill>
+              </a:rPr>
+              <a:t>atual</a:t>
+            </a:r>
+            <a:r>
+              <a:rPr sz="1100" dirty="0">
+                <a:solidFill>
+                  <a:srgbClr val="B0C4DE"/>
+                </a:solidFill>
+              </a:rPr>
+              <a:t> do </a:t>
+            </a:r>
+            <a:r>
+              <a:rPr sz="1100" dirty="0" err="1">
+                <a:solidFill>
+                  <a:srgbClr val="B0C4DE"/>
+                </a:solidFill>
+              </a:rPr>
+              <a:t>cliente</a:t>
+            </a:r>
+            <a:endParaRPr sz="1100" dirty="0">
+              <a:solidFill>
+                <a:srgbClr val="B0C4DE"/>
+              </a:solidFill>
+            </a:endParaRPr>
           </a:p>
           <a:p>
             <a:pPr>
@@ -7421,12 +6638,92 @@
               </a:spcBef>
             </a:pPr>
             <a:r>
-              <a:rPr sz="1100">
-                <a:solidFill>
-                  <a:srgbClr val="B0C4DE"/>
-                </a:solidFill>
-              </a:rPr>
-              <a:t>▸  Solicita aumento com decisão automática por score</a:t>
+              <a:rPr sz="1100" dirty="0">
+                <a:solidFill>
+                  <a:srgbClr val="B0C4DE"/>
+                </a:solidFill>
+              </a:rPr>
+              <a:t>▸  </a:t>
+            </a:r>
+            <a:r>
+              <a:rPr sz="1100" dirty="0" err="1">
+                <a:solidFill>
+                  <a:srgbClr val="B0C4DE"/>
+                </a:solidFill>
+              </a:rPr>
+              <a:t>Solicita</a:t>
+            </a:r>
+            <a:r>
+              <a:rPr sz="1100" dirty="0">
+                <a:solidFill>
+                  <a:srgbClr val="B0C4DE"/>
+                </a:solidFill>
+              </a:rPr>
+              <a:t> </a:t>
+            </a:r>
+            <a:r>
+              <a:rPr sz="1100" dirty="0" err="1">
+                <a:solidFill>
+                  <a:srgbClr val="B0C4DE"/>
+                </a:solidFill>
+              </a:rPr>
+              <a:t>aumento</a:t>
+            </a:r>
+            <a:r>
+              <a:rPr sz="1100" dirty="0">
+                <a:solidFill>
+                  <a:srgbClr val="B0C4DE"/>
+                </a:solidFill>
+              </a:rPr>
+              <a:t> com </a:t>
+            </a:r>
+            <a:r>
+              <a:rPr sz="1100" dirty="0" err="1">
+                <a:solidFill>
+                  <a:srgbClr val="B0C4DE"/>
+                </a:solidFill>
+              </a:rPr>
+              <a:t>decisão</a:t>
+            </a:r>
+            <a:r>
+              <a:rPr sz="1100" dirty="0">
+                <a:solidFill>
+                  <a:srgbClr val="B0C4DE"/>
+                </a:solidFill>
+              </a:rPr>
+              <a:t> </a:t>
+            </a:r>
+            <a:r>
+              <a:rPr sz="1100" dirty="0" err="1">
+                <a:solidFill>
+                  <a:srgbClr val="B0C4DE"/>
+                </a:solidFill>
+              </a:rPr>
+              <a:t>automática</a:t>
+            </a:r>
+            <a:r>
+              <a:rPr sz="1100" dirty="0">
+                <a:solidFill>
+                  <a:srgbClr val="B0C4DE"/>
+                </a:solidFill>
+              </a:rPr>
+              <a:t> </a:t>
+            </a:r>
+            <a:r>
+              <a:rPr sz="1100" dirty="0" err="1">
+                <a:solidFill>
+                  <a:srgbClr val="B0C4DE"/>
+                </a:solidFill>
+              </a:rPr>
+              <a:t>por</a:t>
+            </a:r>
+            <a:r>
+              <a:rPr sz="1100" dirty="0">
+                <a:solidFill>
+                  <a:srgbClr val="B0C4DE"/>
+                </a:solidFill>
+              </a:rPr>
+              <a:t> score</a:t>
             </a:r>
           </a:p>
           <a:p>
@@ -7436,13 +6733,74 @@
               </a:spcBef>
             </a:pPr>
             <a:r>
-              <a:rPr sz="1100">
-                <a:solidFill>
-                  <a:srgbClr val="B0C4DE"/>
-                </a:solidFill>
-              </a:rPr>
-              <a:t>▸  Score insuficiente → oferece entrevista financeira</a:t>
-            </a:r>
+              <a:rPr sz="1100" dirty="0">
+                <a:solidFill>
+                  <a:srgbClr val="B0C4DE"/>
+                </a:solidFill>
+              </a:rPr>
+              <a:t>▸  Score </a:t>
+            </a:r>
+            <a:r>
+              <a:rPr sz="1100" dirty="0" err="1">
+                <a:solidFill>
+                  <a:srgbClr val="B0C4DE"/>
+                </a:solidFill>
+              </a:rPr>
+              <a:t>insuficiente</a:t>
+            </a:r>
+            <a:r>
+              <a:rPr sz="1100" dirty="0">
+                <a:solidFill>
+                  <a:srgbClr val="B0C4DE"/>
+                </a:solidFill>
+              </a:rPr>
+              <a:t> → </a:t>
+            </a:r>
+            <a:r>
+              <a:rPr sz="1100" dirty="0" err="1">
+                <a:solidFill>
+                  <a:srgbClr val="B0C4DE"/>
+                </a:solidFill>
+              </a:rPr>
+              <a:t>oferece</a:t>
+            </a:r>
+            <a:r>
+              <a:rPr sz="1100" dirty="0">
+                <a:solidFill>
+                  <a:srgbClr val="B0C4DE"/>
+                </a:solidFill>
+              </a:rPr>
+              <a:t> </a:t>
+            </a:r>
+            <a:r>
+              <a:rPr sz="1100" dirty="0" err="1">
+                <a:solidFill>
+                  <a:srgbClr val="B0C4DE"/>
+                </a:solidFill>
+              </a:rPr>
+              <a:t>entrevista</a:t>
+            </a:r>
+            <a:r>
+              <a:rPr sz="1100" dirty="0">
+                <a:solidFill>
+                  <a:srgbClr val="B0C4DE"/>
+                </a:solidFill>
+              </a:rPr>
+              <a:t> </a:t>
+            </a:r>
+            <a:r>
+              <a:rPr sz="1100" dirty="0" err="1">
+                <a:solidFill>
+                  <a:srgbClr val="B0C4DE"/>
+                </a:solidFill>
+              </a:rPr>
+              <a:t>financeira</a:t>
+            </a:r>
+            <a:endParaRPr sz="1100" dirty="0">
+              <a:solidFill>
+                <a:srgbClr val="B0C4DE"/>
+              </a:solidFill>
+            </a:endParaRPr>
           </a:p>
           <a:p>
             <a:pPr>
@@ -7451,12 +6809,60 @@
               </a:spcBef>
             </a:pPr>
             <a:r>
-              <a:rPr sz="1100">
-                <a:solidFill>
-                  <a:srgbClr val="B0C4DE"/>
-                </a:solidFill>
-              </a:rPr>
-              <a:t>▸  Registra histórico em CSV com timestamp</a:t>
+              <a:rPr sz="1100" dirty="0">
+                <a:solidFill>
+                  <a:srgbClr val="B0C4DE"/>
+                </a:solidFill>
+              </a:rPr>
+              <a:t>▸  </a:t>
+            </a:r>
+            <a:r>
+              <a:rPr sz="1100" dirty="0" err="1">
+                <a:solidFill>
+                  <a:srgbClr val="B0C4DE"/>
+                </a:solidFill>
+              </a:rPr>
+              <a:t>Registra</a:t>
+            </a:r>
+            <a:r>
+              <a:rPr sz="1100" dirty="0">
+                <a:solidFill>
+                  <a:srgbClr val="B0C4DE"/>
+                </a:solidFill>
+              </a:rPr>
+              <a:t> </a:t>
+            </a:r>
+            <a:r>
+              <a:rPr sz="1100" dirty="0" err="1">
+                <a:solidFill>
+                  <a:srgbClr val="B0C4DE"/>
+                </a:solidFill>
+              </a:rPr>
+              <a:t>histórico</a:t>
+            </a:r>
+            <a:r>
+              <a:rPr sz="1100" dirty="0">
+                <a:solidFill>
+                  <a:srgbClr val="B0C4DE"/>
+                </a:solidFill>
+              </a:rPr>
+              <a:t> </a:t>
+            </a:r>
+            <a:r>
+              <a:rPr sz="1100" dirty="0" err="1">
+                <a:solidFill>
+                  <a:srgbClr val="B0C4DE"/>
+                </a:solidFill>
+              </a:rPr>
+              <a:t>em</a:t>
+            </a:r>
+            <a:r>
+              <a:rPr sz="1100" dirty="0">
+                <a:solidFill>
+                  <a:srgbClr val="B0C4DE"/>
+                </a:solidFill>
+              </a:rPr>
+              <a:t> CSV com timestamp</a:t>
             </a:r>
           </a:p>
           <a:p>
@@ -7466,13 +6872,74 @@
               </a:spcBef>
             </a:pPr>
             <a:r>
+              <a:rPr sz="1100" dirty="0">
+                <a:solidFill>
+                  <a:srgbClr val="B0C4DE"/>
+                </a:solidFill>
+              </a:rPr>
+              <a:t>▸  </a:t>
+            </a:r>
+            <a:r>
+              <a:rPr sz="1100" dirty="0" err="1">
+                <a:solidFill>
+                  <a:srgbClr val="B0C4DE"/>
+                </a:solidFill>
+              </a:rPr>
+              <a:t>Lógica</a:t>
+            </a:r>
+            <a:r>
+              <a:rPr sz="1100" dirty="0">
+                <a:solidFill>
+                  <a:srgbClr val="B0C4DE"/>
+                </a:solidFill>
+              </a:rPr>
+              <a:t> de </a:t>
+            </a:r>
+            <a:r>
+              <a:rPr sz="1100" dirty="0" err="1">
+                <a:solidFill>
+                  <a:srgbClr val="B0C4DE"/>
+                </a:solidFill>
+              </a:rPr>
+              <a:t>aprovação</a:t>
+            </a:r>
+            <a:r>
+              <a:rPr sz="1100" dirty="0">
+                <a:solidFill>
+                  <a:srgbClr val="B0C4DE"/>
+                </a:solidFill>
+              </a:rPr>
+              <a:t> 100% </a:t>
+            </a:r>
+            <a:r>
+              <a:rPr sz="1100" dirty="0" err="1">
+                <a:solidFill>
+                  <a:srgbClr val="B0C4DE"/>
+                </a:solidFill>
+              </a:rPr>
+              <a:t>em</a:t>
+            </a:r>
+            <a:r>
               <a:rPr sz="1100">
                 <a:solidFill>
                   <a:srgbClr val="B0C4DE"/>
                 </a:solidFill>
               </a:rPr>
-              <a:t>▸  Lógica de aprovação 100% em Python (não LLM)</a:t>
-            </a:r>
+              <a:t> </a:t>
+            </a:r>
+            <a:r>
+              <a:rPr sz="1100" smtClean="0">
+                <a:solidFill>
+                  <a:srgbClr val="B0C4DE"/>
+                </a:solidFill>
+              </a:rPr>
+              <a:t>Python</a:t>
+            </a:r>
+            <a:endParaRPr sz="1100" dirty="0">
+              <a:solidFill>
+                <a:srgbClr val="B0C4DE"/>
+              </a:solidFill>
+            </a:endParaRPr>
           </a:p>
         </p:txBody>
       </p:sp>
@@ -7921,6 +7388,13 @@
   <p:clrMapOvr>
     <a:masterClrMapping/>
   </p:clrMapOvr>
+  <p:timing>
+    <p:tnLst>
+      <p:par>
+        <p:cTn id="1" dur="indefinite" restart="never" nodeType="tmRoot"/>
+      </p:par>
+    </p:tnLst>
+  </p:timing>
 </p:sld>
 </file>
 

</xml_diff>

<commit_message>
feat: Atualização de arquivos
</commit_message>
<xml_diff>
--- a/Banco_Agil_Apresentacao.pptx
+++ b/Banco_Agil_Apresentacao.pptx
@@ -4,6 +4,9 @@
   <p:sldMasterIdLst>
     <p:sldMasterId id="2147483648" r:id="rId1"/>
   </p:sldMasterIdLst>
+  <p:notesMasterIdLst>
+    <p:notesMasterId r:id="rId12"/>
+  </p:notesMasterIdLst>
   <p:sldIdLst>
     <p:sldId id="256" r:id="rId2"/>
     <p:sldId id="257" r:id="rId3"/>
@@ -130,6 +133,440 @@
     </p:ext>
   </p:extLst>
 </p:presentation>
+</file>
+
+<file path=ppt/notesMasters/notesMaster1.xml><?xml version="1.0" encoding="utf-8"?>
+<p:notesMaster xmlns:a="http://schemas.openxmlformats.org/drawingml/2006/main" xmlns:r="http://schemas.openxmlformats.org/officeDocument/2006/relationships" xmlns:p="http://schemas.openxmlformats.org/presentationml/2006/main">
+  <p:cSld>
+    <p:bg>
+      <p:bgRef idx="1001">
+        <a:schemeClr val="bg1"/>
+      </p:bgRef>
+    </p:bg>
+    <p:spTree>
+      <p:nvGrpSpPr>
+        <p:cNvPr id="1" name=""/>
+        <p:cNvGrpSpPr/>
+        <p:nvPr/>
+      </p:nvGrpSpPr>
+      <p:grpSpPr>
+        <a:xfrm>
+          <a:off x="0" y="0"/>
+          <a:ext cx="0" cy="0"/>
+          <a:chOff x="0" y="0"/>
+          <a:chExt cx="0" cy="0"/>
+        </a:xfrm>
+      </p:grpSpPr>
+      <p:sp>
+        <p:nvSpPr>
+          <p:cNvPr id="2" name="Espaço Reservado para Cabeçalho 1"/>
+          <p:cNvSpPr>
+            <a:spLocks noGrp="1"/>
+          </p:cNvSpPr>
+          <p:nvPr>
+            <p:ph type="hdr" sz="quarter"/>
+          </p:nvPr>
+        </p:nvSpPr>
+        <p:spPr>
+          <a:xfrm>
+            <a:off x="0" y="0"/>
+            <a:ext cx="2971800" cy="458788"/>
+          </a:xfrm>
+          <a:prstGeom prst="rect">
+            <a:avLst/>
+          </a:prstGeom>
+        </p:spPr>
+        <p:txBody>
+          <a:bodyPr vert="horz" lIns="91440" tIns="45720" rIns="91440" bIns="45720" rtlCol="0"/>
+          <a:lstStyle>
+            <a:lvl1pPr algn="l">
+              <a:defRPr sz="1200"/>
+            </a:lvl1pPr>
+          </a:lstStyle>
+          <a:p>
+            <a:endParaRPr lang="pt-BR"/>
+          </a:p>
+        </p:txBody>
+      </p:sp>
+      <p:sp>
+        <p:nvSpPr>
+          <p:cNvPr id="3" name="Espaço Reservado para Data 2"/>
+          <p:cNvSpPr>
+            <a:spLocks noGrp="1"/>
+          </p:cNvSpPr>
+          <p:nvPr>
+            <p:ph type="dt" idx="1"/>
+          </p:nvPr>
+        </p:nvSpPr>
+        <p:spPr>
+          <a:xfrm>
+            <a:off x="3884613" y="0"/>
+            <a:ext cx="2971800" cy="458788"/>
+          </a:xfrm>
+          <a:prstGeom prst="rect">
+            <a:avLst/>
+          </a:prstGeom>
+        </p:spPr>
+        <p:txBody>
+          <a:bodyPr vert="horz" lIns="91440" tIns="45720" rIns="91440" bIns="45720" rtlCol="0"/>
+          <a:lstStyle>
+            <a:lvl1pPr algn="r">
+              <a:defRPr sz="1200"/>
+            </a:lvl1pPr>
+          </a:lstStyle>
+          <a:p>
+            <a:fld id="{68A95B05-2CAB-4FF6-86DA-55AE86FC331E}" type="datetimeFigureOut">
+              <a:rPr lang="pt-BR" smtClean="0"/>
+              <a:t>26/05/2026</a:t>
+            </a:fld>
+            <a:endParaRPr lang="pt-BR"/>
+          </a:p>
+        </p:txBody>
+      </p:sp>
+      <p:sp>
+        <p:nvSpPr>
+          <p:cNvPr id="4" name="Espaço Reservado para Imagem de Slide 3"/>
+          <p:cNvSpPr>
+            <a:spLocks noGrp="1" noRot="1" noChangeAspect="1"/>
+          </p:cNvSpPr>
+          <p:nvPr>
+            <p:ph type="sldImg" idx="2"/>
+          </p:nvPr>
+        </p:nvSpPr>
+        <p:spPr>
+          <a:xfrm>
+            <a:off x="685800" y="1143000"/>
+            <a:ext cx="5486400" cy="3086100"/>
+          </a:xfrm>
+          <a:prstGeom prst="rect">
+            <a:avLst/>
+          </a:prstGeom>
+          <a:noFill/>
+          <a:ln w="12700">
+            <a:solidFill>
+              <a:prstClr val="black"/>
+            </a:solidFill>
+          </a:ln>
+        </p:spPr>
+        <p:txBody>
+          <a:bodyPr vert="horz" lIns="91440" tIns="45720" rIns="91440" bIns="45720" rtlCol="0" anchor="ctr"/>
+          <a:lstStyle/>
+          <a:p>
+            <a:endParaRPr lang="pt-BR"/>
+          </a:p>
+        </p:txBody>
+      </p:sp>
+      <p:sp>
+        <p:nvSpPr>
+          <p:cNvPr id="5" name="Espaço Reservado para Anotações 4"/>
+          <p:cNvSpPr>
+            <a:spLocks noGrp="1"/>
+          </p:cNvSpPr>
+          <p:nvPr>
+            <p:ph type="body" sz="quarter" idx="3"/>
+          </p:nvPr>
+        </p:nvSpPr>
+        <p:spPr>
+          <a:xfrm>
+            <a:off x="685800" y="4400550"/>
+            <a:ext cx="5486400" cy="3600450"/>
+          </a:xfrm>
+          <a:prstGeom prst="rect">
+            <a:avLst/>
+          </a:prstGeom>
+        </p:spPr>
+        <p:txBody>
+          <a:bodyPr vert="horz" lIns="91440" tIns="45720" rIns="91440" bIns="45720" rtlCol="0"/>
+          <a:lstStyle/>
+          <a:p>
+            <a:pPr lvl="0"/>
+            <a:r>
+              <a:rPr lang="pt-BR" smtClean="0"/>
+              <a:t>Clique para editar o texto mestre</a:t>
+            </a:r>
+          </a:p>
+          <a:p>
+            <a:pPr lvl="1"/>
+            <a:r>
+              <a:rPr lang="pt-BR" smtClean="0"/>
+              <a:t>Segundo nível</a:t>
+            </a:r>
+          </a:p>
+          <a:p>
+            <a:pPr lvl="2"/>
+            <a:r>
+              <a:rPr lang="pt-BR" smtClean="0"/>
+              <a:t>Terceiro nível</a:t>
+            </a:r>
+          </a:p>
+          <a:p>
+            <a:pPr lvl="3"/>
+            <a:r>
+              <a:rPr lang="pt-BR" smtClean="0"/>
+              <a:t>Quarto nível</a:t>
+            </a:r>
+          </a:p>
+          <a:p>
+            <a:pPr lvl="4"/>
+            <a:r>
+              <a:rPr lang="pt-BR" smtClean="0"/>
+              <a:t>Quinto nível</a:t>
+            </a:r>
+            <a:endParaRPr lang="pt-BR"/>
+          </a:p>
+        </p:txBody>
+      </p:sp>
+      <p:sp>
+        <p:nvSpPr>
+          <p:cNvPr id="6" name="Espaço Reservado para Rodapé 5"/>
+          <p:cNvSpPr>
+            <a:spLocks noGrp="1"/>
+          </p:cNvSpPr>
+          <p:nvPr>
+            <p:ph type="ftr" sz="quarter" idx="4"/>
+          </p:nvPr>
+        </p:nvSpPr>
+        <p:spPr>
+          <a:xfrm>
+            <a:off x="0" y="8685213"/>
+            <a:ext cx="2971800" cy="458787"/>
+          </a:xfrm>
+          <a:prstGeom prst="rect">
+            <a:avLst/>
+          </a:prstGeom>
+        </p:spPr>
+        <p:txBody>
+          <a:bodyPr vert="horz" lIns="91440" tIns="45720" rIns="91440" bIns="45720" rtlCol="0" anchor="b"/>
+          <a:lstStyle>
+            <a:lvl1pPr algn="l">
+              <a:defRPr sz="1200"/>
+            </a:lvl1pPr>
+          </a:lstStyle>
+          <a:p>
+            <a:endParaRPr lang="pt-BR"/>
+          </a:p>
+        </p:txBody>
+      </p:sp>
+      <p:sp>
+        <p:nvSpPr>
+          <p:cNvPr id="7" name="Espaço Reservado para Número de Slide 6"/>
+          <p:cNvSpPr>
+            <a:spLocks noGrp="1"/>
+          </p:cNvSpPr>
+          <p:nvPr>
+            <p:ph type="sldNum" sz="quarter" idx="5"/>
+          </p:nvPr>
+        </p:nvSpPr>
+        <p:spPr>
+          <a:xfrm>
+            <a:off x="3884613" y="8685213"/>
+            <a:ext cx="2971800" cy="458787"/>
+          </a:xfrm>
+          <a:prstGeom prst="rect">
+            <a:avLst/>
+          </a:prstGeom>
+        </p:spPr>
+        <p:txBody>
+          <a:bodyPr vert="horz" lIns="91440" tIns="45720" rIns="91440" bIns="45720" rtlCol="0" anchor="b"/>
+          <a:lstStyle>
+            <a:lvl1pPr algn="r">
+              <a:defRPr sz="1200"/>
+            </a:lvl1pPr>
+          </a:lstStyle>
+          <a:p>
+            <a:fld id="{B0E3B387-B50C-48B4-8AA8-3E2C5D647D69}" type="slidenum">
+              <a:rPr lang="pt-BR" smtClean="0"/>
+              <a:t>‹nº›</a:t>
+            </a:fld>
+            <a:endParaRPr lang="pt-BR"/>
+          </a:p>
+        </p:txBody>
+      </p:sp>
+    </p:spTree>
+    <p:extLst>
+      <p:ext uri="{BB962C8B-B14F-4D97-AF65-F5344CB8AC3E}">
+        <p14:creationId xmlns:p14="http://schemas.microsoft.com/office/powerpoint/2010/main" val="4147792808"/>
+      </p:ext>
+    </p:extLst>
+  </p:cSld>
+  <p:clrMap bg1="lt1" tx1="dk1" bg2="lt2" tx2="dk2" accent1="accent1" accent2="accent2" accent3="accent3" accent4="accent4" accent5="accent5" accent6="accent6" hlink="hlink" folHlink="folHlink"/>
+  <p:notesStyle>
+    <a:lvl1pPr marL="0" algn="l" defTabSz="914400" rtl="0" eaLnBrk="1" latinLnBrk="0" hangingPunct="1">
+      <a:defRPr sz="1200" kern="1200">
+        <a:solidFill>
+          <a:schemeClr val="tx1"/>
+        </a:solidFill>
+        <a:latin typeface="+mn-lt"/>
+        <a:ea typeface="+mn-ea"/>
+        <a:cs typeface="+mn-cs"/>
+      </a:defRPr>
+    </a:lvl1pPr>
+    <a:lvl2pPr marL="457200" algn="l" defTabSz="914400" rtl="0" eaLnBrk="1" latinLnBrk="0" hangingPunct="1">
+      <a:defRPr sz="1200" kern="1200">
+        <a:solidFill>
+          <a:schemeClr val="tx1"/>
+        </a:solidFill>
+        <a:latin typeface="+mn-lt"/>
+        <a:ea typeface="+mn-ea"/>
+        <a:cs typeface="+mn-cs"/>
+      </a:defRPr>
+    </a:lvl2pPr>
+    <a:lvl3pPr marL="914400" algn="l" defTabSz="914400" rtl="0" eaLnBrk="1" latinLnBrk="0" hangingPunct="1">
+      <a:defRPr sz="1200" kern="1200">
+        <a:solidFill>
+          <a:schemeClr val="tx1"/>
+        </a:solidFill>
+        <a:latin typeface="+mn-lt"/>
+        <a:ea typeface="+mn-ea"/>
+        <a:cs typeface="+mn-cs"/>
+      </a:defRPr>
+    </a:lvl3pPr>
+    <a:lvl4pPr marL="1371600" algn="l" defTabSz="914400" rtl="0" eaLnBrk="1" latinLnBrk="0" hangingPunct="1">
+      <a:defRPr sz="1200" kern="1200">
+        <a:solidFill>
+          <a:schemeClr val="tx1"/>
+        </a:solidFill>
+        <a:latin typeface="+mn-lt"/>
+        <a:ea typeface="+mn-ea"/>
+        <a:cs typeface="+mn-cs"/>
+      </a:defRPr>
+    </a:lvl4pPr>
+    <a:lvl5pPr marL="1828800" algn="l" defTabSz="914400" rtl="0" eaLnBrk="1" latinLnBrk="0" hangingPunct="1">
+      <a:defRPr sz="1200" kern="1200">
+        <a:solidFill>
+          <a:schemeClr val="tx1"/>
+        </a:solidFill>
+        <a:latin typeface="+mn-lt"/>
+        <a:ea typeface="+mn-ea"/>
+        <a:cs typeface="+mn-cs"/>
+      </a:defRPr>
+    </a:lvl5pPr>
+    <a:lvl6pPr marL="2286000" algn="l" defTabSz="914400" rtl="0" eaLnBrk="1" latinLnBrk="0" hangingPunct="1">
+      <a:defRPr sz="1200" kern="1200">
+        <a:solidFill>
+          <a:schemeClr val="tx1"/>
+        </a:solidFill>
+        <a:latin typeface="+mn-lt"/>
+        <a:ea typeface="+mn-ea"/>
+        <a:cs typeface="+mn-cs"/>
+      </a:defRPr>
+    </a:lvl6pPr>
+    <a:lvl7pPr marL="2743200" algn="l" defTabSz="914400" rtl="0" eaLnBrk="1" latinLnBrk="0" hangingPunct="1">
+      <a:defRPr sz="1200" kern="1200">
+        <a:solidFill>
+          <a:schemeClr val="tx1"/>
+        </a:solidFill>
+        <a:latin typeface="+mn-lt"/>
+        <a:ea typeface="+mn-ea"/>
+        <a:cs typeface="+mn-cs"/>
+      </a:defRPr>
+    </a:lvl7pPr>
+    <a:lvl8pPr marL="3200400" algn="l" defTabSz="914400" rtl="0" eaLnBrk="1" latinLnBrk="0" hangingPunct="1">
+      <a:defRPr sz="1200" kern="1200">
+        <a:solidFill>
+          <a:schemeClr val="tx1"/>
+        </a:solidFill>
+        <a:latin typeface="+mn-lt"/>
+        <a:ea typeface="+mn-ea"/>
+        <a:cs typeface="+mn-cs"/>
+      </a:defRPr>
+    </a:lvl8pPr>
+    <a:lvl9pPr marL="3657600" algn="l" defTabSz="914400" rtl="0" eaLnBrk="1" latinLnBrk="0" hangingPunct="1">
+      <a:defRPr sz="1200" kern="1200">
+        <a:solidFill>
+          <a:schemeClr val="tx1"/>
+        </a:solidFill>
+        <a:latin typeface="+mn-lt"/>
+        <a:ea typeface="+mn-ea"/>
+        <a:cs typeface="+mn-cs"/>
+      </a:defRPr>
+    </a:lvl9pPr>
+  </p:notesStyle>
+</p:notesMaster>
+</file>
+
+<file path=ppt/notesSlides/notesSlide1.xml><?xml version="1.0" encoding="utf-8"?>
+<p:notes xmlns:a="http://schemas.openxmlformats.org/drawingml/2006/main" xmlns:r="http://schemas.openxmlformats.org/officeDocument/2006/relationships" xmlns:p="http://schemas.openxmlformats.org/presentationml/2006/main">
+  <p:cSld>
+    <p:spTree>
+      <p:nvGrpSpPr>
+        <p:cNvPr id="1" name=""/>
+        <p:cNvGrpSpPr/>
+        <p:nvPr/>
+      </p:nvGrpSpPr>
+      <p:grpSpPr>
+        <a:xfrm>
+          <a:off x="0" y="0"/>
+          <a:ext cx="0" cy="0"/>
+          <a:chOff x="0" y="0"/>
+          <a:chExt cx="0" cy="0"/>
+        </a:xfrm>
+      </p:grpSpPr>
+      <p:sp>
+        <p:nvSpPr>
+          <p:cNvPr id="2" name="Espaço Reservado para Imagem de Slide 1"/>
+          <p:cNvSpPr>
+            <a:spLocks noGrp="1" noRot="1" noChangeAspect="1"/>
+          </p:cNvSpPr>
+          <p:nvPr>
+            <p:ph type="sldImg"/>
+          </p:nvPr>
+        </p:nvSpPr>
+        <p:spPr/>
+      </p:sp>
+      <p:sp>
+        <p:nvSpPr>
+          <p:cNvPr id="3" name="Espaço Reservado para Anotações 2"/>
+          <p:cNvSpPr>
+            <a:spLocks noGrp="1"/>
+          </p:cNvSpPr>
+          <p:nvPr>
+            <p:ph type="body" idx="1"/>
+          </p:nvPr>
+        </p:nvSpPr>
+        <p:spPr/>
+        <p:txBody>
+          <a:bodyPr/>
+          <a:lstStyle/>
+          <a:p>
+            <a:endParaRPr lang="pt-BR" dirty="0"/>
+          </a:p>
+        </p:txBody>
+      </p:sp>
+      <p:sp>
+        <p:nvSpPr>
+          <p:cNvPr id="4" name="Espaço Reservado para Número de Slide 3"/>
+          <p:cNvSpPr>
+            <a:spLocks noGrp="1"/>
+          </p:cNvSpPr>
+          <p:nvPr>
+            <p:ph type="sldNum" sz="quarter" idx="10"/>
+          </p:nvPr>
+        </p:nvSpPr>
+        <p:spPr/>
+        <p:txBody>
+          <a:bodyPr/>
+          <a:lstStyle/>
+          <a:p>
+            <a:fld id="{B0E3B387-B50C-48B4-8AA8-3E2C5D647D69}" type="slidenum">
+              <a:rPr lang="pt-BR" smtClean="0"/>
+              <a:t>8</a:t>
+            </a:fld>
+            <a:endParaRPr lang="pt-BR"/>
+          </a:p>
+        </p:txBody>
+      </p:sp>
+    </p:spTree>
+    <p:extLst>
+      <p:ext uri="{BB962C8B-B14F-4D97-AF65-F5344CB8AC3E}">
+        <p14:creationId xmlns:p14="http://schemas.microsoft.com/office/powerpoint/2010/main" val="1393056342"/>
+      </p:ext>
+    </p:extLst>
+  </p:cSld>
+  <p:clrMapOvr>
+    <a:masterClrMapping/>
+  </p:clrMapOvr>
+</p:notes>
 </file>
 
 <file path=ppt/slideLayouts/slideLayout1.xml><?xml version="1.0" encoding="utf-8"?>
@@ -9027,7 +9464,7 @@
         <p:spPr>
           <a:xfrm>
             <a:off x="4434840" y="4617720"/>
-            <a:ext cx="3474720" cy="1188720"/>
+            <a:ext cx="3474720" cy="415498"/>
           </a:xfrm>
           <a:prstGeom prst="rect">
             <a:avLst/>
@@ -9042,14 +9479,187 @@
           <a:p>
             <a:pPr algn="l"/>
             <a:r>
-              <a:rPr sz="1050" b="0" i="0">
-                <a:solidFill>
-                  <a:srgbClr val="B0C4DE"/>
-                </a:solidFill>
-              </a:rPr>
-              <a:t>Gratuita, sem autenticação, cobertura ampla de moedas.
-Retorno em tempo real com compra, venda e variação.</a:t>
-            </a:r>
+              <a:rPr sz="1050" b="0" i="0" dirty="0" err="1">
+                <a:solidFill>
+                  <a:srgbClr val="B0C4DE"/>
+                </a:solidFill>
+              </a:rPr>
+              <a:t>Gratuita</a:t>
+            </a:r>
+            <a:r>
+              <a:rPr sz="1050" b="0" i="0" dirty="0">
+                <a:solidFill>
+                  <a:srgbClr val="B0C4DE"/>
+                </a:solidFill>
+              </a:rPr>
+              <a:t>, </a:t>
+            </a:r>
+            <a:r>
+              <a:rPr sz="1050" b="0" i="0" dirty="0" err="1">
+                <a:solidFill>
+                  <a:srgbClr val="B0C4DE"/>
+                </a:solidFill>
+              </a:rPr>
+              <a:t>sem</a:t>
+            </a:r>
+            <a:r>
+              <a:rPr sz="1050" b="0" i="0" dirty="0">
+                <a:solidFill>
+                  <a:srgbClr val="B0C4DE"/>
+                </a:solidFill>
+              </a:rPr>
+              <a:t> </a:t>
+            </a:r>
+            <a:r>
+              <a:rPr sz="1050" b="0" i="0" dirty="0" err="1">
+                <a:solidFill>
+                  <a:srgbClr val="B0C4DE"/>
+                </a:solidFill>
+              </a:rPr>
+              <a:t>autenticação</a:t>
+            </a:r>
+            <a:r>
+              <a:rPr sz="1050" b="0" i="0" dirty="0">
+                <a:solidFill>
+                  <a:srgbClr val="B0C4DE"/>
+                </a:solidFill>
+              </a:rPr>
+              <a:t>, </a:t>
+            </a:r>
+            <a:r>
+              <a:rPr sz="1050" b="0" i="0" dirty="0" err="1">
+                <a:solidFill>
+                  <a:srgbClr val="B0C4DE"/>
+                </a:solidFill>
+              </a:rPr>
+              <a:t>cobertura</a:t>
+            </a:r>
+            <a:r>
+              <a:rPr sz="1050" b="0" i="0" dirty="0">
+                <a:solidFill>
+                  <a:srgbClr val="B0C4DE"/>
+                </a:solidFill>
+              </a:rPr>
+              <a:t> </a:t>
+            </a:r>
+            <a:r>
+              <a:rPr sz="1050" b="0" i="0" dirty="0" err="1">
+                <a:solidFill>
+                  <a:srgbClr val="B0C4DE"/>
+                </a:solidFill>
+              </a:rPr>
+              <a:t>ampla</a:t>
+            </a:r>
+            <a:r>
+              <a:rPr sz="1050" b="0" i="0" dirty="0">
+                <a:solidFill>
+                  <a:srgbClr val="B0C4DE"/>
+                </a:solidFill>
+              </a:rPr>
+              <a:t> de </a:t>
+            </a:r>
+            <a:r>
+              <a:rPr sz="1050" b="0" i="0" dirty="0" err="1">
+                <a:solidFill>
+                  <a:srgbClr val="B0C4DE"/>
+                </a:solidFill>
+              </a:rPr>
+              <a:t>moedas</a:t>
+            </a:r>
+            <a:r>
+              <a:rPr sz="1050" b="0" i="0" dirty="0">
+                <a:solidFill>
+                  <a:srgbClr val="B0C4DE"/>
+                </a:solidFill>
+              </a:rPr>
+              <a:t>.
+</a:t>
+            </a:r>
+            <a:r>
+              <a:rPr sz="1050" b="0" i="0" dirty="0" err="1">
+                <a:solidFill>
+                  <a:srgbClr val="B0C4DE"/>
+                </a:solidFill>
+              </a:rPr>
+              <a:t>Retorno</a:t>
+            </a:r>
+            <a:r>
+              <a:rPr sz="1050" b="0" i="0" dirty="0">
+                <a:solidFill>
+                  <a:srgbClr val="B0C4DE"/>
+                </a:solidFill>
+              </a:rPr>
+              <a:t> </a:t>
+            </a:r>
+            <a:r>
+              <a:rPr sz="1050" b="0" i="0" dirty="0" err="1">
+                <a:solidFill>
+                  <a:srgbClr val="B0C4DE"/>
+                </a:solidFill>
+              </a:rPr>
+              <a:t>em</a:t>
+            </a:r>
+            <a:r>
+              <a:rPr sz="1050" b="0" i="0" dirty="0">
+                <a:solidFill>
+                  <a:srgbClr val="B0C4DE"/>
+                </a:solidFill>
+              </a:rPr>
+              <a:t> tempo real com </a:t>
+            </a:r>
+            <a:r>
+              <a:rPr lang="pt-BR" sz="1050" b="0" i="0" dirty="0" smtClean="0">
+                <a:solidFill>
+                  <a:srgbClr val="B0C4DE"/>
+                </a:solidFill>
+              </a:rPr>
+              <a:t>valores de </a:t>
+            </a:r>
+            <a:r>
+              <a:rPr sz="1050" b="0" i="0" dirty="0" err="1" smtClean="0">
+                <a:solidFill>
+                  <a:srgbClr val="B0C4DE"/>
+                </a:solidFill>
+              </a:rPr>
+              <a:t>compra</a:t>
+            </a:r>
+            <a:r>
+              <a:rPr lang="pt-BR" sz="1050" b="0" i="0" dirty="0" smtClean="0">
+                <a:solidFill>
+                  <a:srgbClr val="B0C4DE"/>
+                </a:solidFill>
+              </a:rPr>
+              <a:t> e</a:t>
+            </a:r>
+            <a:r>
+              <a:rPr sz="1050" b="0" i="0" dirty="0" smtClean="0">
+                <a:solidFill>
+                  <a:srgbClr val="B0C4DE"/>
+                </a:solidFill>
+              </a:rPr>
+              <a:t> </a:t>
+            </a:r>
+            <a:r>
+              <a:rPr sz="1050" b="0" i="0" dirty="0" err="1" smtClean="0">
+                <a:solidFill>
+                  <a:srgbClr val="B0C4DE"/>
+                </a:solidFill>
+              </a:rPr>
+              <a:t>venda</a:t>
+            </a:r>
+            <a:r>
+              <a:rPr sz="1050" b="0" i="0" dirty="0" smtClean="0">
+                <a:solidFill>
+                  <a:srgbClr val="B0C4DE"/>
+                </a:solidFill>
+              </a:rPr>
+              <a:t>.</a:t>
+            </a:r>
+            <a:endParaRPr sz="1050" b="0" i="0" dirty="0">
+              <a:solidFill>
+                <a:srgbClr val="B0C4DE"/>
+              </a:solidFill>
+            </a:endParaRPr>
           </a:p>
         </p:txBody>
       </p:sp>
@@ -12317,12 +12927,76 @@
               </a:spcBef>
             </a:pPr>
             <a:r>
-              <a:rPr sz="1200">
-                <a:solidFill>
-                  <a:srgbClr val="FFFFFF"/>
-                </a:solidFill>
-              </a:rPr>
-              <a:t>✅  Validação matemática de CPF (dígitos verificadores)</a:t>
+              <a:rPr sz="1200" dirty="0">
+                <a:solidFill>
+                  <a:srgbClr val="FFFFFF"/>
+                </a:solidFill>
+              </a:rPr>
+              <a:t>✅  </a:t>
+            </a:r>
+            <a:r>
+              <a:rPr sz="1200" dirty="0" err="1">
+                <a:solidFill>
+                  <a:srgbClr val="FFFFFF"/>
+                </a:solidFill>
+              </a:rPr>
+              <a:t>Validação</a:t>
+            </a:r>
+            <a:r>
+              <a:rPr sz="1200" dirty="0">
+                <a:solidFill>
+                  <a:srgbClr val="FFFFFF"/>
+                </a:solidFill>
+              </a:rPr>
+              <a:t> </a:t>
+            </a:r>
+            <a:r>
+              <a:rPr sz="1200" dirty="0" err="1">
+                <a:solidFill>
+                  <a:srgbClr val="FFFFFF"/>
+                </a:solidFill>
+              </a:rPr>
+              <a:t>matemática</a:t>
+            </a:r>
+            <a:r>
+              <a:rPr sz="1200" dirty="0">
+                <a:solidFill>
+                  <a:srgbClr val="FFFFFF"/>
+                </a:solidFill>
+              </a:rPr>
+              <a:t> de CPF (</a:t>
+            </a:r>
+            <a:r>
+              <a:rPr sz="1200" dirty="0" err="1">
+                <a:solidFill>
+                  <a:srgbClr val="FFFFFF"/>
+                </a:solidFill>
+              </a:rPr>
+              <a:t>dígitos</a:t>
+            </a:r>
+            <a:r>
+              <a:rPr sz="1200" dirty="0">
+                <a:solidFill>
+                  <a:srgbClr val="FFFFFF"/>
+                </a:solidFill>
+              </a:rPr>
+              <a:t> </a:t>
+            </a:r>
+            <a:r>
+              <a:rPr sz="1200" dirty="0" err="1">
+                <a:solidFill>
+                  <a:srgbClr val="FFFFFF"/>
+                </a:solidFill>
+              </a:rPr>
+              <a:t>verificadores</a:t>
+            </a:r>
+            <a:r>
+              <a:rPr sz="1200" dirty="0">
+                <a:solidFill>
+                  <a:srgbClr val="FFFFFF"/>
+                </a:solidFill>
+              </a:rPr>
+              <a:t>)</a:t>
             </a:r>
           </a:p>
           <a:p>
@@ -12332,13 +13006,42 @@
               </a:spcBef>
             </a:pPr>
             <a:r>
-              <a:rPr sz="1200">
-                <a:solidFill>
-                  <a:srgbClr val="FFFFFF"/>
-                </a:solidFill>
-              </a:rPr>
-              <a:t>✅  Autenticação CPF + data de nascimento</a:t>
-            </a:r>
+              <a:rPr sz="1200" dirty="0">
+                <a:solidFill>
+                  <a:srgbClr val="FFFFFF"/>
+                </a:solidFill>
+              </a:rPr>
+              <a:t>✅  </a:t>
+            </a:r>
+            <a:r>
+              <a:rPr sz="1200" dirty="0" err="1">
+                <a:solidFill>
+                  <a:srgbClr val="FFFFFF"/>
+                </a:solidFill>
+              </a:rPr>
+              <a:t>Autenticação</a:t>
+            </a:r>
+            <a:r>
+              <a:rPr sz="1200" dirty="0">
+                <a:solidFill>
+                  <a:srgbClr val="FFFFFF"/>
+                </a:solidFill>
+              </a:rPr>
+              <a:t> CPF + data de </a:t>
+            </a:r>
+            <a:r>
+              <a:rPr sz="1200" dirty="0" err="1">
+                <a:solidFill>
+                  <a:srgbClr val="FFFFFF"/>
+                </a:solidFill>
+              </a:rPr>
+              <a:t>nascimento</a:t>
+            </a:r>
+            <a:endParaRPr sz="1200" dirty="0">
+              <a:solidFill>
+                <a:srgbClr val="FFFFFF"/>
+              </a:solidFill>
+            </a:endParaRPr>
           </a:p>
           <a:p>
             <a:pPr>
@@ -12347,13 +13050,90 @@
               </a:spcBef>
             </a:pPr>
             <a:r>
-              <a:rPr sz="1200">
-                <a:solidFill>
-                  <a:srgbClr val="FFFFFF"/>
-                </a:solidFill>
-              </a:rPr>
-              <a:t>✅  Controle de tentativas: 3 CPFs inválidos e 3 falhas de auth</a:t>
-            </a:r>
+              <a:rPr sz="1200" dirty="0">
+                <a:solidFill>
+                  <a:srgbClr val="FFFFFF"/>
+                </a:solidFill>
+              </a:rPr>
+              <a:t>✅  </a:t>
+            </a:r>
+            <a:r>
+              <a:rPr sz="1200" dirty="0" err="1">
+                <a:solidFill>
+                  <a:srgbClr val="FFFFFF"/>
+                </a:solidFill>
+              </a:rPr>
+              <a:t>Controle</a:t>
+            </a:r>
+            <a:r>
+              <a:rPr sz="1200" dirty="0">
+                <a:solidFill>
+                  <a:srgbClr val="FFFFFF"/>
+                </a:solidFill>
+              </a:rPr>
+              <a:t> de </a:t>
+            </a:r>
+            <a:r>
+              <a:rPr sz="1200" dirty="0" err="1">
+                <a:solidFill>
+                  <a:srgbClr val="FFFFFF"/>
+                </a:solidFill>
+              </a:rPr>
+              <a:t>tentativas</a:t>
+            </a:r>
+            <a:r>
+              <a:rPr sz="1200" dirty="0">
+                <a:solidFill>
+                  <a:srgbClr val="FFFFFF"/>
+                </a:solidFill>
+              </a:rPr>
+              <a:t>: 3 CPFs </a:t>
+            </a:r>
+            <a:r>
+              <a:rPr sz="1200" dirty="0" err="1">
+                <a:solidFill>
+                  <a:srgbClr val="FFFFFF"/>
+                </a:solidFill>
+              </a:rPr>
+              <a:t>inválidos</a:t>
+            </a:r>
+            <a:r>
+              <a:rPr sz="1200" dirty="0">
+                <a:solidFill>
+                  <a:srgbClr val="FFFFFF"/>
+                </a:solidFill>
+              </a:rPr>
+              <a:t> e 3 </a:t>
+            </a:r>
+            <a:r>
+              <a:rPr sz="1200" dirty="0" err="1">
+                <a:solidFill>
+                  <a:srgbClr val="FFFFFF"/>
+                </a:solidFill>
+              </a:rPr>
+              <a:t>falhas</a:t>
+            </a:r>
+            <a:r>
+              <a:rPr sz="1200" dirty="0">
+                <a:solidFill>
+                  <a:srgbClr val="FFFFFF"/>
+                </a:solidFill>
+              </a:rPr>
+              <a:t> de </a:t>
+            </a:r>
+            <a:r>
+              <a:rPr sz="1200" dirty="0" err="1">
+                <a:solidFill>
+                  <a:srgbClr val="FFFFFF"/>
+                </a:solidFill>
+              </a:rPr>
+              <a:t>auth</a:t>
+            </a:r>
+            <a:endParaRPr sz="1200" dirty="0">
+              <a:solidFill>
+                <a:srgbClr val="FFFFFF"/>
+              </a:solidFill>
+            </a:endParaRPr>
           </a:p>
           <a:p>
             <a:pPr>
@@ -12362,13 +13142,90 @@
               </a:spcBef>
             </a:pPr>
             <a:r>
-              <a:rPr sz="1200">
-                <a:solidFill>
-                  <a:srgbClr val="FFFFFF"/>
-                </a:solidFill>
-              </a:rPr>
-              <a:t>✅  Encerramento automático por excesso de tentativas</a:t>
-            </a:r>
+              <a:rPr sz="1200" dirty="0">
+                <a:solidFill>
+                  <a:srgbClr val="FFFFFF"/>
+                </a:solidFill>
+              </a:rPr>
+              <a:t>✅  </a:t>
+            </a:r>
+            <a:r>
+              <a:rPr sz="1200" dirty="0" err="1">
+                <a:solidFill>
+                  <a:srgbClr val="FFFFFF"/>
+                </a:solidFill>
+              </a:rPr>
+              <a:t>Encerramento</a:t>
+            </a:r>
+            <a:r>
+              <a:rPr sz="1200" dirty="0">
+                <a:solidFill>
+                  <a:srgbClr val="FFFFFF"/>
+                </a:solidFill>
+              </a:rPr>
+              <a:t> </a:t>
+            </a:r>
+            <a:r>
+              <a:rPr sz="1200" dirty="0" err="1">
+                <a:solidFill>
+                  <a:srgbClr val="FFFFFF"/>
+                </a:solidFill>
+              </a:rPr>
+              <a:t>automático</a:t>
+            </a:r>
+            <a:r>
+              <a:rPr sz="1200" dirty="0">
+                <a:solidFill>
+                  <a:srgbClr val="FFFFFF"/>
+                </a:solidFill>
+              </a:rPr>
+              <a:t> </a:t>
+            </a:r>
+            <a:r>
+              <a:rPr sz="1200" dirty="0" err="1">
+                <a:solidFill>
+                  <a:srgbClr val="FFFFFF"/>
+                </a:solidFill>
+              </a:rPr>
+              <a:t>por</a:t>
+            </a:r>
+            <a:r>
+              <a:rPr sz="1200" dirty="0">
+                <a:solidFill>
+                  <a:srgbClr val="FFFFFF"/>
+                </a:solidFill>
+              </a:rPr>
+              <a:t> </a:t>
+            </a:r>
+            <a:r>
+              <a:rPr sz="1200" dirty="0" err="1">
+                <a:solidFill>
+                  <a:srgbClr val="FFFFFF"/>
+                </a:solidFill>
+              </a:rPr>
+              <a:t>excesso</a:t>
+            </a:r>
+            <a:r>
+              <a:rPr sz="1200" dirty="0">
+                <a:solidFill>
+                  <a:srgbClr val="FFFFFF"/>
+                </a:solidFill>
+              </a:rPr>
+              <a:t> de </a:t>
+            </a:r>
+            <a:r>
+              <a:rPr sz="1200" dirty="0" err="1">
+                <a:solidFill>
+                  <a:srgbClr val="FFFFFF"/>
+                </a:solidFill>
+              </a:rPr>
+              <a:t>tentativas</a:t>
+            </a:r>
+            <a:endParaRPr sz="1200" dirty="0">
+              <a:solidFill>
+                <a:srgbClr val="FFFFFF"/>
+              </a:solidFill>
+            </a:endParaRPr>
           </a:p>
           <a:p>
             <a:pPr>
@@ -12377,12 +13234,76 @@
               </a:spcBef>
             </a:pPr>
             <a:r>
-              <a:rPr sz="1200">
-                <a:solidFill>
-                  <a:srgbClr val="FFFFFF"/>
-                </a:solidFill>
-              </a:rPr>
-              <a:t>✅  Consulta de limite de crédito em tempo real</a:t>
+              <a:rPr sz="1200" dirty="0">
+                <a:solidFill>
+                  <a:srgbClr val="FFFFFF"/>
+                </a:solidFill>
+              </a:rPr>
+              <a:t>✅  </a:t>
+            </a:r>
+            <a:r>
+              <a:rPr sz="1200" dirty="0" err="1">
+                <a:solidFill>
+                  <a:srgbClr val="FFFFFF"/>
+                </a:solidFill>
+              </a:rPr>
+              <a:t>Consulta</a:t>
+            </a:r>
+            <a:r>
+              <a:rPr sz="1200" dirty="0">
+                <a:solidFill>
+                  <a:srgbClr val="FFFFFF"/>
+                </a:solidFill>
+              </a:rPr>
+              <a:t> de </a:t>
+            </a:r>
+            <a:r>
+              <a:rPr sz="1200" dirty="0" err="1">
+                <a:solidFill>
+                  <a:srgbClr val="FFFFFF"/>
+                </a:solidFill>
+              </a:rPr>
+              <a:t>limite</a:t>
+            </a:r>
+            <a:r>
+              <a:rPr sz="1200" dirty="0">
+                <a:solidFill>
+                  <a:srgbClr val="FFFFFF"/>
+                </a:solidFill>
+              </a:rPr>
+              <a:t> de </a:t>
+            </a:r>
+            <a:r>
+              <a:rPr sz="1200" dirty="0" err="1">
+                <a:solidFill>
+                  <a:srgbClr val="FFFFFF"/>
+                </a:solidFill>
+              </a:rPr>
+              <a:t>crédito</a:t>
+            </a:r>
+            <a:r>
+              <a:rPr sz="1200" dirty="0">
+                <a:solidFill>
+                  <a:srgbClr val="FFFFFF"/>
+                </a:solidFill>
+              </a:rPr>
+              <a:t> </a:t>
+            </a:r>
+            <a:r>
+              <a:rPr sz="1200" dirty="0" err="1">
+                <a:solidFill>
+                  <a:srgbClr val="FFFFFF"/>
+                </a:solidFill>
+              </a:rPr>
+              <a:t>em</a:t>
+            </a:r>
+            <a:r>
+              <a:rPr sz="1200" dirty="0">
+                <a:solidFill>
+                  <a:srgbClr val="FFFFFF"/>
+                </a:solidFill>
+              </a:rPr>
+              <a:t> tempo real</a:t>
             </a:r>
           </a:p>
           <a:p>
@@ -12392,12 +13313,76 @@
               </a:spcBef>
             </a:pPr>
             <a:r>
-              <a:rPr sz="1200">
-                <a:solidFill>
-                  <a:srgbClr val="FFFFFF"/>
-                </a:solidFill>
-              </a:rPr>
-              <a:t>✅  Aprovação/rejeição automática por score (Python)</a:t>
+              <a:rPr sz="1200" dirty="0">
+                <a:solidFill>
+                  <a:srgbClr val="FFFFFF"/>
+                </a:solidFill>
+              </a:rPr>
+              <a:t>✅  </a:t>
+            </a:r>
+            <a:r>
+              <a:rPr sz="1200" dirty="0" err="1">
+                <a:solidFill>
+                  <a:srgbClr val="FFFFFF"/>
+                </a:solidFill>
+              </a:rPr>
+              <a:t>Aprovação</a:t>
+            </a:r>
+            <a:r>
+              <a:rPr sz="1200" dirty="0">
+                <a:solidFill>
+                  <a:srgbClr val="FFFFFF"/>
+                </a:solidFill>
+              </a:rPr>
+              <a:t>/</a:t>
+            </a:r>
+            <a:r>
+              <a:rPr sz="1200" dirty="0" err="1">
+                <a:solidFill>
+                  <a:srgbClr val="FFFFFF"/>
+                </a:solidFill>
+              </a:rPr>
+              <a:t>rejeição</a:t>
+            </a:r>
+            <a:r>
+              <a:rPr sz="1200" dirty="0">
+                <a:solidFill>
+                  <a:srgbClr val="FFFFFF"/>
+                </a:solidFill>
+              </a:rPr>
+              <a:t> </a:t>
+            </a:r>
+            <a:r>
+              <a:rPr sz="1200" dirty="0" err="1">
+                <a:solidFill>
+                  <a:srgbClr val="FFFFFF"/>
+                </a:solidFill>
+              </a:rPr>
+              <a:t>automática</a:t>
+            </a:r>
+            <a:r>
+              <a:rPr sz="1200" dirty="0">
+                <a:solidFill>
+                  <a:srgbClr val="FFFFFF"/>
+                </a:solidFill>
+              </a:rPr>
+              <a:t> </a:t>
+            </a:r>
+            <a:r>
+              <a:rPr sz="1200" dirty="0" err="1">
+                <a:solidFill>
+                  <a:srgbClr val="FFFFFF"/>
+                </a:solidFill>
+              </a:rPr>
+              <a:t>por</a:t>
+            </a:r>
+            <a:r>
+              <a:rPr sz="1200" dirty="0">
+                <a:solidFill>
+                  <a:srgbClr val="FFFFFF"/>
+                </a:solidFill>
+              </a:rPr>
+              <a:t> score (Python)</a:t>
             </a:r>
           </a:p>
           <a:p>
@@ -12407,12 +13392,60 @@
               </a:spcBef>
             </a:pPr>
             <a:r>
-              <a:rPr sz="1200">
-                <a:solidFill>
-                  <a:srgbClr val="FFFFFF"/>
-                </a:solidFill>
-              </a:rPr>
-              <a:t>✅  Registro histórico de solicitações com timestamp ISO 8601</a:t>
+              <a:rPr sz="1200" dirty="0">
+                <a:solidFill>
+                  <a:srgbClr val="FFFFFF"/>
+                </a:solidFill>
+              </a:rPr>
+              <a:t>✅  </a:t>
+            </a:r>
+            <a:r>
+              <a:rPr sz="1200" dirty="0" err="1">
+                <a:solidFill>
+                  <a:srgbClr val="FFFFFF"/>
+                </a:solidFill>
+              </a:rPr>
+              <a:t>Registro</a:t>
+            </a:r>
+            <a:r>
+              <a:rPr sz="1200" dirty="0">
+                <a:solidFill>
+                  <a:srgbClr val="FFFFFF"/>
+                </a:solidFill>
+              </a:rPr>
+              <a:t> </a:t>
+            </a:r>
+            <a:r>
+              <a:rPr sz="1200" dirty="0" err="1">
+                <a:solidFill>
+                  <a:srgbClr val="FFFFFF"/>
+                </a:solidFill>
+              </a:rPr>
+              <a:t>histórico</a:t>
+            </a:r>
+            <a:r>
+              <a:rPr sz="1200" dirty="0">
+                <a:solidFill>
+                  <a:srgbClr val="FFFFFF"/>
+                </a:solidFill>
+              </a:rPr>
+              <a:t> de </a:t>
+            </a:r>
+            <a:r>
+              <a:rPr sz="1200" dirty="0" err="1">
+                <a:solidFill>
+                  <a:srgbClr val="FFFFFF"/>
+                </a:solidFill>
+              </a:rPr>
+              <a:t>solicitações</a:t>
+            </a:r>
+            <a:r>
+              <a:rPr sz="1200" dirty="0">
+                <a:solidFill>
+                  <a:srgbClr val="FFFFFF"/>
+                </a:solidFill>
+              </a:rPr>
+              <a:t> com timestamp ISO 8601</a:t>
             </a:r>
           </a:p>
           <a:p>
@@ -12422,12 +13455,108 @@
               </a:spcBef>
             </a:pPr>
             <a:r>
-              <a:rPr sz="1200">
-                <a:solidFill>
-                  <a:srgbClr val="FFFFFF"/>
-                </a:solidFill>
-              </a:rPr>
-              <a:t>✅  Entrevista financeira conversacional (1 pergunta por vez)</a:t>
+              <a:rPr sz="1200" dirty="0">
+                <a:solidFill>
+                  <a:srgbClr val="FFFFFF"/>
+                </a:solidFill>
+              </a:rPr>
+              <a:t>✅  </a:t>
+            </a:r>
+            <a:r>
+              <a:rPr sz="1200" dirty="0" err="1">
+                <a:solidFill>
+                  <a:srgbClr val="FFFFFF"/>
+                </a:solidFill>
+              </a:rPr>
+              <a:t>Entrevista</a:t>
+            </a:r>
+            <a:r>
+              <a:rPr sz="1200" dirty="0">
+                <a:solidFill>
+                  <a:srgbClr val="FFFFFF"/>
+                </a:solidFill>
+              </a:rPr>
+              <a:t> </a:t>
+            </a:r>
+            <a:r>
+              <a:rPr sz="1200" dirty="0" err="1">
+                <a:solidFill>
+                  <a:srgbClr val="FFFFFF"/>
+                </a:solidFill>
+              </a:rPr>
+              <a:t>financeira</a:t>
+            </a:r>
+            <a:r>
+              <a:rPr sz="1200" dirty="0">
+                <a:solidFill>
+                  <a:srgbClr val="FFFFFF"/>
+                </a:solidFill>
+              </a:rPr>
+              <a:t> </a:t>
+            </a:r>
+            <a:r>
+              <a:rPr sz="1200" dirty="0" err="1">
+                <a:solidFill>
+                  <a:srgbClr val="FFFFFF"/>
+                </a:solidFill>
+              </a:rPr>
+              <a:t>conversacional</a:t>
+            </a:r>
+            <a:r>
+              <a:rPr sz="1200" dirty="0">
+                <a:solidFill>
+                  <a:srgbClr val="FFFFFF"/>
+                </a:solidFill>
+              </a:rPr>
+              <a:t> (1 </a:t>
+            </a:r>
+            <a:r>
+              <a:rPr sz="1200" dirty="0" err="1">
+                <a:solidFill>
+                  <a:srgbClr val="FFFFFF"/>
+                </a:solidFill>
+              </a:rPr>
+              <a:t>pergunta</a:t>
+            </a:r>
+            <a:r>
+              <a:rPr sz="1200" dirty="0">
+                <a:solidFill>
+                  <a:srgbClr val="FFFFFF"/>
+                </a:solidFill>
+              </a:rPr>
+              <a:t> </a:t>
+            </a:r>
+            <a:r>
+              <a:rPr sz="1200" dirty="0" err="1">
+                <a:solidFill>
+                  <a:srgbClr val="FFFFFF"/>
+                </a:solidFill>
+              </a:rPr>
+              <a:t>por</a:t>
+            </a:r>
+            <a:r>
+              <a:rPr sz="1200" dirty="0">
+                <a:solidFill>
+                  <a:srgbClr val="FFFFFF"/>
+                </a:solidFill>
+              </a:rPr>
+              <a:t> </a:t>
+            </a:r>
+            <a:r>
+              <a:rPr sz="1200" dirty="0" err="1">
+                <a:solidFill>
+                  <a:srgbClr val="FFFFFF"/>
+                </a:solidFill>
+              </a:rPr>
+              <a:t>vez</a:t>
+            </a:r>
+            <a:r>
+              <a:rPr sz="1200" dirty="0">
+                <a:solidFill>
+                  <a:srgbClr val="FFFFFF"/>
+                </a:solidFill>
+              </a:rPr>
+              <a:t>)</a:t>
             </a:r>
           </a:p>
           <a:p>
@@ -12437,13 +13566,58 @@
               </a:spcBef>
             </a:pPr>
             <a:r>
-              <a:rPr sz="1200">
-                <a:solidFill>
-                  <a:srgbClr val="FFFFFF"/>
-                </a:solidFill>
-              </a:rPr>
-              <a:t>✅  Fórmula própria de score com 5 variáveis</a:t>
-            </a:r>
+              <a:rPr sz="1200" dirty="0">
+                <a:solidFill>
+                  <a:srgbClr val="FFFFFF"/>
+                </a:solidFill>
+              </a:rPr>
+              <a:t>✅  </a:t>
+            </a:r>
+            <a:r>
+              <a:rPr sz="1200" dirty="0" err="1">
+                <a:solidFill>
+                  <a:srgbClr val="FFFFFF"/>
+                </a:solidFill>
+              </a:rPr>
+              <a:t>Fórmula</a:t>
+            </a:r>
+            <a:r>
+              <a:rPr sz="1200" dirty="0">
+                <a:solidFill>
+                  <a:srgbClr val="FFFFFF"/>
+                </a:solidFill>
+              </a:rPr>
+              <a:t> </a:t>
+            </a:r>
+            <a:r>
+              <a:rPr sz="1200" dirty="0" err="1">
+                <a:solidFill>
+                  <a:srgbClr val="FFFFFF"/>
+                </a:solidFill>
+              </a:rPr>
+              <a:t>própria</a:t>
+            </a:r>
+            <a:r>
+              <a:rPr sz="1200" dirty="0">
+                <a:solidFill>
+                  <a:srgbClr val="FFFFFF"/>
+                </a:solidFill>
+              </a:rPr>
+              <a:t> de score com 5 </a:t>
+            </a:r>
+            <a:r>
+              <a:rPr sz="1200" dirty="0" err="1">
+                <a:solidFill>
+                  <a:srgbClr val="FFFFFF"/>
+                </a:solidFill>
+              </a:rPr>
+              <a:t>variáveis</a:t>
+            </a:r>
+            <a:endParaRPr sz="1200" dirty="0">
+              <a:solidFill>
+                <a:srgbClr val="FFFFFF"/>
+              </a:solidFill>
+            </a:endParaRPr>
           </a:p>
         </p:txBody>
       </p:sp>
@@ -12456,7 +13630,7 @@
         <p:spPr>
           <a:xfrm>
             <a:off x="6309360" y="1508760"/>
-            <a:ext cx="5486400" cy="5029200"/>
+            <a:ext cx="5486400" cy="2267287"/>
           </a:xfrm>
           <a:prstGeom prst="rect">
             <a:avLst/>
@@ -12475,13 +13649,74 @@
               </a:spcBef>
             </a:pPr>
             <a:r>
-              <a:rPr sz="1200">
-                <a:solidFill>
-                  <a:srgbClr val="FFFFFF"/>
-                </a:solidFill>
-              </a:rPr>
-              <a:t>✅  Atualização automática de score no CSV após entrevista</a:t>
-            </a:r>
+              <a:rPr sz="1200" dirty="0">
+                <a:solidFill>
+                  <a:srgbClr val="FFFFFF"/>
+                </a:solidFill>
+              </a:rPr>
+              <a:t>✅  </a:t>
+            </a:r>
+            <a:r>
+              <a:rPr sz="1200" dirty="0" err="1">
+                <a:solidFill>
+                  <a:srgbClr val="FFFFFF"/>
+                </a:solidFill>
+              </a:rPr>
+              <a:t>Atualização</a:t>
+            </a:r>
+            <a:r>
+              <a:rPr sz="1200" dirty="0">
+                <a:solidFill>
+                  <a:srgbClr val="FFFFFF"/>
+                </a:solidFill>
+              </a:rPr>
+              <a:t> </a:t>
+            </a:r>
+            <a:r>
+              <a:rPr sz="1200" dirty="0" err="1">
+                <a:solidFill>
+                  <a:srgbClr val="FFFFFF"/>
+                </a:solidFill>
+              </a:rPr>
+              <a:t>automática</a:t>
+            </a:r>
+            <a:r>
+              <a:rPr sz="1200" dirty="0">
+                <a:solidFill>
+                  <a:srgbClr val="FFFFFF"/>
+                </a:solidFill>
+              </a:rPr>
+              <a:t> de score no CSV </a:t>
+            </a:r>
+            <a:r>
+              <a:rPr sz="1200" dirty="0" err="1">
+                <a:solidFill>
+                  <a:srgbClr val="FFFFFF"/>
+                </a:solidFill>
+              </a:rPr>
+              <a:t>após</a:t>
+            </a:r>
+            <a:r>
+              <a:rPr sz="1200" dirty="0">
+                <a:solidFill>
+                  <a:srgbClr val="FFFFFF"/>
+                </a:solidFill>
+              </a:rPr>
+              <a:t> </a:t>
+            </a:r>
+            <a:r>
+              <a:rPr sz="1200" dirty="0" err="1">
+                <a:solidFill>
+                  <a:srgbClr val="FFFFFF"/>
+                </a:solidFill>
+              </a:rPr>
+              <a:t>entrevista</a:t>
+            </a:r>
+            <a:endParaRPr sz="1200" dirty="0">
+              <a:solidFill>
+                <a:srgbClr val="FFFFFF"/>
+              </a:solidFill>
+            </a:endParaRPr>
           </a:p>
           <a:p>
             <a:pPr>
@@ -12490,13 +13725,90 @@
               </a:spcBef>
             </a:pPr>
             <a:r>
-              <a:rPr sz="1200">
-                <a:solidFill>
-                  <a:srgbClr val="FFFFFF"/>
-                </a:solidFill>
-              </a:rPr>
-              <a:t>✅  Redirecionamento automático crédito → entrevista → crédito</a:t>
-            </a:r>
+              <a:rPr sz="1200" dirty="0">
+                <a:solidFill>
+                  <a:srgbClr val="FFFFFF"/>
+                </a:solidFill>
+              </a:rPr>
+              <a:t>✅  </a:t>
+            </a:r>
+            <a:r>
+              <a:rPr sz="1200" dirty="0" err="1">
+                <a:solidFill>
+                  <a:srgbClr val="FFFFFF"/>
+                </a:solidFill>
+              </a:rPr>
+              <a:t>Redirecionamento</a:t>
+            </a:r>
+            <a:r>
+              <a:rPr sz="1200" dirty="0">
+                <a:solidFill>
+                  <a:srgbClr val="FFFFFF"/>
+                </a:solidFill>
+              </a:rPr>
+              <a:t> </a:t>
+            </a:r>
+            <a:r>
+              <a:rPr sz="1200" dirty="0" err="1">
+                <a:solidFill>
+                  <a:srgbClr val="FFFFFF"/>
+                </a:solidFill>
+              </a:rPr>
+              <a:t>automático</a:t>
+            </a:r>
+            <a:r>
+              <a:rPr sz="1200" dirty="0">
+                <a:solidFill>
+                  <a:srgbClr val="FFFFFF"/>
+                </a:solidFill>
+              </a:rPr>
+              <a:t> </a:t>
+            </a:r>
+            <a:r>
+              <a:rPr sz="1200" dirty="0" err="1">
+                <a:solidFill>
+                  <a:srgbClr val="FFFFFF"/>
+                </a:solidFill>
+              </a:rPr>
+              <a:t>crédito</a:t>
+            </a:r>
+            <a:r>
+              <a:rPr sz="1200" dirty="0">
+                <a:solidFill>
+                  <a:srgbClr val="FFFFFF"/>
+                </a:solidFill>
+              </a:rPr>
+              <a:t> → </a:t>
+            </a:r>
+            <a:r>
+              <a:rPr sz="1200" dirty="0" err="1">
+                <a:solidFill>
+                  <a:srgbClr val="FFFFFF"/>
+                </a:solidFill>
+              </a:rPr>
+              <a:t>entrevista</a:t>
+            </a:r>
+            <a:r>
+              <a:rPr sz="1200" dirty="0">
+                <a:solidFill>
+                  <a:srgbClr val="FFFFFF"/>
+                </a:solidFill>
+              </a:rPr>
+              <a:t> → </a:t>
+            </a:r>
+            <a:r>
+              <a:rPr sz="1200" dirty="0" err="1">
+                <a:solidFill>
+                  <a:srgbClr val="FFFFFF"/>
+                </a:solidFill>
+              </a:rPr>
+              <a:t>crédito</a:t>
+            </a:r>
+            <a:endParaRPr sz="1200" dirty="0">
+              <a:solidFill>
+                <a:srgbClr val="FFFFFF"/>
+              </a:solidFill>
+            </a:endParaRPr>
           </a:p>
           <a:p>
             <a:pPr>
@@ -12505,13 +13817,106 @@
               </a:spcBef>
             </a:pPr>
             <a:r>
-              <a:rPr sz="1200">
-                <a:solidFill>
-                  <a:srgbClr val="FFFFFF"/>
-                </a:solidFill>
-              </a:rPr>
-              <a:t>✅  Botões Sim/Não na UI para aceite da entrevista</a:t>
-            </a:r>
+              <a:rPr sz="1200" dirty="0">
+                <a:solidFill>
+                  <a:srgbClr val="FFFFFF"/>
+                </a:solidFill>
+              </a:rPr>
+              <a:t>✅  </a:t>
+            </a:r>
+            <a:r>
+              <a:rPr sz="1200" dirty="0" err="1">
+                <a:solidFill>
+                  <a:srgbClr val="FFFFFF"/>
+                </a:solidFill>
+              </a:rPr>
+              <a:t>Botões</a:t>
+            </a:r>
+            <a:r>
+              <a:rPr sz="1200" dirty="0">
+                <a:solidFill>
+                  <a:srgbClr val="FFFFFF"/>
+                </a:solidFill>
+              </a:rPr>
+              <a:t> </a:t>
+            </a:r>
+            <a:r>
+              <a:rPr sz="1200" dirty="0" err="1">
+                <a:solidFill>
+                  <a:srgbClr val="FFFFFF"/>
+                </a:solidFill>
+              </a:rPr>
+              <a:t>Sim</a:t>
+            </a:r>
+            <a:r>
+              <a:rPr sz="1200" dirty="0">
+                <a:solidFill>
+                  <a:srgbClr val="FFFFFF"/>
+                </a:solidFill>
+              </a:rPr>
+              <a:t>/</a:t>
+            </a:r>
+            <a:r>
+              <a:rPr sz="1200" dirty="0" err="1">
+                <a:solidFill>
+                  <a:srgbClr val="FFFFFF"/>
+                </a:solidFill>
+              </a:rPr>
+              <a:t>Não</a:t>
+            </a:r>
+            <a:r>
+              <a:rPr sz="1200" dirty="0">
+                <a:solidFill>
+                  <a:srgbClr val="FFFFFF"/>
+                </a:solidFill>
+              </a:rPr>
+              <a:t> </a:t>
+            </a:r>
+            <a:r>
+              <a:rPr sz="1200" dirty="0" err="1">
+                <a:solidFill>
+                  <a:srgbClr val="FFFFFF"/>
+                </a:solidFill>
+              </a:rPr>
+              <a:t>na</a:t>
+            </a:r>
+            <a:r>
+              <a:rPr sz="1200" dirty="0">
+                <a:solidFill>
+                  <a:srgbClr val="FFFFFF"/>
+                </a:solidFill>
+              </a:rPr>
+              <a:t> UI para </a:t>
+            </a:r>
+            <a:r>
+              <a:rPr sz="1200" dirty="0" err="1">
+                <a:solidFill>
+                  <a:srgbClr val="FFFFFF"/>
+                </a:solidFill>
+              </a:rPr>
+              <a:t>aceite</a:t>
+            </a:r>
+            <a:r>
+              <a:rPr sz="1200" dirty="0">
+                <a:solidFill>
+                  <a:srgbClr val="FFFFFF"/>
+                </a:solidFill>
+              </a:rPr>
+              <a:t> da </a:t>
+            </a:r>
+            <a:r>
+              <a:rPr sz="1200" dirty="0" err="1">
+                <a:solidFill>
+                  <a:srgbClr val="FFFFFF"/>
+                </a:solidFill>
+              </a:rPr>
+              <a:t>entrevista</a:t>
+            </a:r>
+            <a:endParaRPr sz="1200" dirty="0">
+              <a:solidFill>
+                <a:srgbClr val="FFFFFF"/>
+              </a:solidFill>
+            </a:endParaRPr>
           </a:p>
           <a:p>
             <a:pPr>
@@ -12520,12 +13925,60 @@
               </a:spcBef>
             </a:pPr>
             <a:r>
-              <a:rPr sz="1200">
-                <a:solidFill>
-                  <a:srgbClr val="FFFFFF"/>
-                </a:solidFill>
-              </a:rPr>
-              <a:t>✅  Cotação de câmbio em tempo real (USD, EUR, GBP, ARS…)</a:t>
+              <a:rPr sz="1200" dirty="0">
+                <a:solidFill>
+                  <a:srgbClr val="FFFFFF"/>
+                </a:solidFill>
+              </a:rPr>
+              <a:t>✅  </a:t>
+            </a:r>
+            <a:r>
+              <a:rPr sz="1200" dirty="0" err="1">
+                <a:solidFill>
+                  <a:srgbClr val="FFFFFF"/>
+                </a:solidFill>
+              </a:rPr>
+              <a:t>Cotação</a:t>
+            </a:r>
+            <a:r>
+              <a:rPr sz="1200" dirty="0">
+                <a:solidFill>
+                  <a:srgbClr val="FFFFFF"/>
+                </a:solidFill>
+              </a:rPr>
+              <a:t> de </a:t>
+            </a:r>
+            <a:r>
+              <a:rPr sz="1200" dirty="0" err="1">
+                <a:solidFill>
+                  <a:srgbClr val="FFFFFF"/>
+                </a:solidFill>
+              </a:rPr>
+              <a:t>câmbio</a:t>
+            </a:r>
+            <a:r>
+              <a:rPr sz="1200" dirty="0">
+                <a:solidFill>
+                  <a:srgbClr val="FFFFFF"/>
+                </a:solidFill>
+              </a:rPr>
+              <a:t> </a:t>
+            </a:r>
+            <a:r>
+              <a:rPr sz="1200" dirty="0" err="1">
+                <a:solidFill>
+                  <a:srgbClr val="FFFFFF"/>
+                </a:solidFill>
+              </a:rPr>
+              <a:t>em</a:t>
+            </a:r>
+            <a:r>
+              <a:rPr sz="1200" dirty="0">
+                <a:solidFill>
+                  <a:srgbClr val="FFFFFF"/>
+                </a:solidFill>
+              </a:rPr>
+              <a:t> tempo real (USD, EUR, GBP, ARS…)</a:t>
             </a:r>
           </a:p>
           <a:p>
@@ -12535,13 +13988,58 @@
               </a:spcBef>
             </a:pPr>
             <a:r>
-              <a:rPr sz="1200">
-                <a:solidFill>
-                  <a:srgbClr val="FFFFFF"/>
-                </a:solidFill>
-              </a:rPr>
-              <a:t>✅  Transição transparente entre agentes (1 assistente ao cliente)</a:t>
-            </a:r>
+              <a:rPr sz="1200" dirty="0">
+                <a:solidFill>
+                  <a:srgbClr val="FFFFFF"/>
+                </a:solidFill>
+              </a:rPr>
+              <a:t>✅  </a:t>
+            </a:r>
+            <a:r>
+              <a:rPr sz="1200" dirty="0" err="1">
+                <a:solidFill>
+                  <a:srgbClr val="FFFFFF"/>
+                </a:solidFill>
+              </a:rPr>
+              <a:t>Transição</a:t>
+            </a:r>
+            <a:r>
+              <a:rPr sz="1200" dirty="0">
+                <a:solidFill>
+                  <a:srgbClr val="FFFFFF"/>
+                </a:solidFill>
+              </a:rPr>
+              <a:t> </a:t>
+            </a:r>
+            <a:r>
+              <a:rPr sz="1200" dirty="0" err="1">
+                <a:solidFill>
+                  <a:srgbClr val="FFFFFF"/>
+                </a:solidFill>
+              </a:rPr>
+              <a:t>transparente</a:t>
+            </a:r>
+            <a:r>
+              <a:rPr sz="1200" dirty="0">
+                <a:solidFill>
+                  <a:srgbClr val="FFFFFF"/>
+                </a:solidFill>
+              </a:rPr>
+              <a:t> entre </a:t>
+            </a:r>
+            <a:r>
+              <a:rPr sz="1200" dirty="0" err="1" smtClean="0">
+                <a:solidFill>
+                  <a:srgbClr val="FFFFFF"/>
+                </a:solidFill>
+              </a:rPr>
+              <a:t>agentes</a:t>
+            </a:r>
+            <a:endParaRPr sz="1200" dirty="0">
+              <a:solidFill>
+                <a:srgbClr val="FFFFFF"/>
+              </a:solidFill>
+            </a:endParaRPr>
           </a:p>
           <a:p>
             <a:pPr>
@@ -12550,13 +14048,74 @@
               </a:spcBef>
             </a:pPr>
             <a:r>
-              <a:rPr sz="1200">
-                <a:solidFill>
-                  <a:srgbClr val="FFFFFF"/>
-                </a:solidFill>
-              </a:rPr>
-              <a:t>✅  System prompt dinâmico com contexto do cliente autenticado</a:t>
-            </a:r>
+              <a:rPr sz="1200" dirty="0">
+                <a:solidFill>
+                  <a:srgbClr val="FFFFFF"/>
+                </a:solidFill>
+              </a:rPr>
+              <a:t>✅  System prompt </a:t>
+            </a:r>
+            <a:r>
+              <a:rPr sz="1200" dirty="0" err="1">
+                <a:solidFill>
+                  <a:srgbClr val="FFFFFF"/>
+                </a:solidFill>
+              </a:rPr>
+              <a:t>dinâmico</a:t>
+            </a:r>
+            <a:r>
+              <a:rPr sz="1200" dirty="0">
+                <a:solidFill>
+                  <a:srgbClr val="FFFFFF"/>
+                </a:solidFill>
+              </a:rPr>
+              <a:t> com </a:t>
+            </a:r>
+            <a:r>
+              <a:rPr sz="1200" dirty="0" err="1">
+                <a:solidFill>
+                  <a:srgbClr val="FFFFFF"/>
+                </a:solidFill>
+              </a:rPr>
+              <a:t>contexto</a:t>
+            </a:r>
+            <a:r>
+              <a:rPr sz="1200" dirty="0">
+                <a:solidFill>
+                  <a:srgbClr val="FFFFFF"/>
+                </a:solidFill>
+              </a:rPr>
+              <a:t> do </a:t>
+            </a:r>
+            <a:r>
+              <a:rPr sz="1200" dirty="0" err="1">
+                <a:solidFill>
+                  <a:srgbClr val="FFFFFF"/>
+                </a:solidFill>
+              </a:rPr>
+              <a:t>cliente</a:t>
+            </a:r>
+            <a:r>
+              <a:rPr sz="1200" dirty="0">
+                <a:solidFill>
+                  <a:srgbClr val="FFFFFF"/>
+                </a:solidFill>
+              </a:rPr>
+              <a:t> </a:t>
+            </a:r>
+            <a:r>
+              <a:rPr sz="1200" dirty="0" err="1">
+                <a:solidFill>
+                  <a:srgbClr val="FFFFFF"/>
+                </a:solidFill>
+              </a:rPr>
+              <a:t>autenticado</a:t>
+            </a:r>
+            <a:endParaRPr sz="1200" dirty="0">
+              <a:solidFill>
+                <a:srgbClr val="FFFFFF"/>
+              </a:solidFill>
+            </a:endParaRPr>
           </a:p>
           <a:p>
             <a:pPr>
@@ -12565,12 +14124,92 @@
               </a:spcBef>
             </a:pPr>
             <a:r>
-              <a:rPr sz="1200">
-                <a:solidFill>
-                  <a:srgbClr val="FFFFFF"/>
-                </a:solidFill>
-              </a:rPr>
-              <a:t>✅  Interface Streamlit com design bancário moderno (tema escuro)</a:t>
+              <a:rPr sz="1200" dirty="0">
+                <a:solidFill>
+                  <a:srgbClr val="FFFFFF"/>
+                </a:solidFill>
+              </a:rPr>
+              <a:t>✅  Interface </a:t>
+            </a:r>
+            <a:r>
+              <a:rPr sz="1200" dirty="0" err="1">
+                <a:solidFill>
+                  <a:srgbClr val="FFFFFF"/>
+                </a:solidFill>
+              </a:rPr>
+              <a:t>Streamlit</a:t>
+            </a:r>
+            <a:r>
+              <a:rPr sz="1200" dirty="0">
+                <a:solidFill>
+                  <a:srgbClr val="FFFFFF"/>
+                </a:solidFill>
+              </a:rPr>
+              <a:t> com design </a:t>
+            </a:r>
+            <a:r>
+              <a:rPr sz="1200" dirty="0" err="1">
+                <a:solidFill>
+                  <a:srgbClr val="FFFFFF"/>
+                </a:solidFill>
+              </a:rPr>
+              <a:t>bancário</a:t>
+            </a:r>
+            <a:r>
+              <a:rPr sz="1200" dirty="0">
+                <a:solidFill>
+                  <a:srgbClr val="FFFFFF"/>
+                </a:solidFill>
+              </a:rPr>
+              <a:t> </a:t>
+            </a:r>
+            <a:r>
+              <a:rPr sz="1200" dirty="0" err="1">
+                <a:solidFill>
+                  <a:srgbClr val="FFFFFF"/>
+                </a:solidFill>
+              </a:rPr>
+              <a:t>moderno</a:t>
+            </a:r>
+            <a:r>
+              <a:rPr sz="1200" dirty="0">
+                <a:solidFill>
+                  <a:srgbClr val="FFFFFF"/>
+                </a:solidFill>
+              </a:rPr>
+              <a:t> (</a:t>
+            </a:r>
+            <a:r>
+              <a:rPr sz="1200" dirty="0" err="1">
+                <a:solidFill>
+                  <a:srgbClr val="FFFFFF"/>
+                </a:solidFill>
+              </a:rPr>
+              <a:t>tema</a:t>
+            </a:r>
+            <a:r>
+              <a:rPr sz="1200" dirty="0">
+                <a:solidFill>
+                  <a:srgbClr val="FFFFFF"/>
+                </a:solidFill>
+              </a:rPr>
+              <a:t> </a:t>
+            </a:r>
+            <a:r>
+              <a:rPr sz="1200" dirty="0" err="1">
+                <a:solidFill>
+                  <a:srgbClr val="FFFFFF"/>
+                </a:solidFill>
+              </a:rPr>
+              <a:t>escuro</a:t>
+            </a:r>
+            <a:r>
+              <a:rPr sz="1200" dirty="0">
+                <a:solidFill>
+                  <a:srgbClr val="FFFFFF"/>
+                </a:solidFill>
+              </a:rPr>
+              <a:t>)</a:t>
             </a:r>
           </a:p>
           <a:p>
@@ -12580,13 +14219,58 @@
               </a:spcBef>
             </a:pPr>
             <a:r>
-              <a:rPr sz="1200">
-                <a:solidFill>
-                  <a:srgbClr val="FFFFFF"/>
-                </a:solidFill>
-              </a:rPr>
-              <a:t>✅  Sidebar com score, limite e agente ativo</a:t>
-            </a:r>
+              <a:rPr sz="1200" dirty="0">
+                <a:solidFill>
+                  <a:srgbClr val="FFFFFF"/>
+                </a:solidFill>
+              </a:rPr>
+              <a:t>✅  Sidebar com score, </a:t>
+            </a:r>
+            <a:r>
+              <a:rPr sz="1200" dirty="0" err="1">
+                <a:solidFill>
+                  <a:srgbClr val="FFFFFF"/>
+                </a:solidFill>
+              </a:rPr>
+              <a:t>limite</a:t>
+            </a:r>
+            <a:r>
+              <a:rPr sz="1200" dirty="0">
+                <a:solidFill>
+                  <a:srgbClr val="FFFFFF"/>
+                </a:solidFill>
+              </a:rPr>
+              <a:t> e </a:t>
+            </a:r>
+            <a:r>
+              <a:rPr sz="1200" dirty="0" err="1">
+                <a:solidFill>
+                  <a:srgbClr val="FFFFFF"/>
+                </a:solidFill>
+              </a:rPr>
+              <a:t>agente</a:t>
+            </a:r>
+            <a:r>
+              <a:rPr sz="1200" dirty="0">
+                <a:solidFill>
+                  <a:srgbClr val="FFFFFF"/>
+                </a:solidFill>
+              </a:rPr>
+              <a:t> </a:t>
+            </a:r>
+            <a:r>
+              <a:rPr sz="1200" dirty="0" err="1">
+                <a:solidFill>
+                  <a:srgbClr val="FFFFFF"/>
+                </a:solidFill>
+              </a:rPr>
+              <a:t>ativo</a:t>
+            </a:r>
+            <a:endParaRPr sz="1200" dirty="0">
+              <a:solidFill>
+                <a:srgbClr val="FFFFFF"/>
+              </a:solidFill>
+            </a:endParaRPr>
           </a:p>
           <a:p>
             <a:pPr>
@@ -12595,12 +14279,44 @@
               </a:spcBef>
             </a:pPr>
             <a:r>
-              <a:rPr sz="1200">
-                <a:solidFill>
-                  <a:srgbClr val="FFFFFF"/>
-                </a:solidFill>
-              </a:rPr>
-              <a:t>✅  Logging centralizado com alertas Slack / e-mail</a:t>
+              <a:rPr sz="1200" dirty="0">
+                <a:solidFill>
+                  <a:srgbClr val="FFFFFF"/>
+                </a:solidFill>
+              </a:rPr>
+              <a:t>✅  Logging </a:t>
+            </a:r>
+            <a:r>
+              <a:rPr sz="1200" dirty="0" err="1">
+                <a:solidFill>
+                  <a:srgbClr val="FFFFFF"/>
+                </a:solidFill>
+              </a:rPr>
+              <a:t>centralizado</a:t>
+            </a:r>
+            <a:r>
+              <a:rPr sz="1200" dirty="0">
+                <a:solidFill>
+                  <a:srgbClr val="FFFFFF"/>
+                </a:solidFill>
+              </a:rPr>
+              <a:t> com </a:t>
+            </a:r>
+            <a:r>
+              <a:rPr sz="1200" dirty="0" err="1">
+                <a:solidFill>
+                  <a:srgbClr val="FFFFFF"/>
+                </a:solidFill>
+              </a:rPr>
+              <a:t>alertas</a:t>
+            </a:r>
+            <a:r>
+              <a:rPr sz="1200" dirty="0">
+                <a:solidFill>
+                  <a:srgbClr val="FFFFFF"/>
+                </a:solidFill>
+              </a:rPr>
+              <a:t> Slack / e-mail</a:t>
             </a:r>
           </a:p>
         </p:txBody>
@@ -12978,7 +14694,7 @@
         <p:spPr>
           <a:xfrm>
             <a:off x="502920" y="1892807"/>
-            <a:ext cx="5394960" cy="457200"/>
+            <a:ext cx="5394960" cy="384721"/>
           </a:xfrm>
           <a:prstGeom prst="rect">
             <a:avLst/>
@@ -12993,13 +14709,58 @@
           <a:p>
             <a:pPr algn="l"/>
             <a:r>
-              <a:rPr sz="950" b="0" i="1">
-                <a:solidFill>
-                  <a:srgbClr val="B0C4DE"/>
-                </a:solidFill>
-              </a:rPr>
-              <a:t>Gemini 2.5 Flash recusa tool calls em operações financeiras por treinamento de segurança.</a:t>
-            </a:r>
+              <a:rPr sz="950" b="0" i="1" dirty="0">
+                <a:solidFill>
+                  <a:srgbClr val="B0C4DE"/>
+                </a:solidFill>
+              </a:rPr>
+              <a:t>Gemini 2.5 Flash </a:t>
+            </a:r>
+            <a:r>
+              <a:rPr lang="pt-BR" sz="950" i="1" dirty="0" smtClean="0">
+                <a:solidFill>
+                  <a:srgbClr val="B0C4DE"/>
+                </a:solidFill>
+              </a:rPr>
+              <a:t>recusava </a:t>
+            </a:r>
+            <a:r>
+              <a:rPr lang="pt-BR" sz="950" i="1" dirty="0">
+                <a:solidFill>
+                  <a:srgbClr val="B0C4DE"/>
+                </a:solidFill>
+              </a:rPr>
+              <a:t>chamar </a:t>
+            </a:r>
+            <a:r>
+              <a:rPr lang="pt-BR" sz="950" i="1" dirty="0" err="1">
+                <a:solidFill>
+                  <a:srgbClr val="B0C4DE"/>
+                </a:solidFill>
+              </a:rPr>
+              <a:t>solicitar_aumento_limite</a:t>
+            </a:r>
+            <a:r>
+              <a:rPr lang="pt-BR" sz="950" i="1" dirty="0">
+                <a:solidFill>
+                  <a:srgbClr val="B0C4DE"/>
+                </a:solidFill>
+              </a:rPr>
+              <a:t> por treinamento de segurança — respondia "não consigo atender essa solicitação</a:t>
+            </a:r>
+            <a:r>
+              <a:rPr lang="pt-BR" sz="950" i="1" dirty="0" smtClean="0">
+                <a:solidFill>
+                  <a:srgbClr val="B0C4DE"/>
+                </a:solidFill>
+              </a:rPr>
+              <a:t>".</a:t>
+            </a:r>
+            <a:endParaRPr lang="pt-BR" sz="950" i="1" dirty="0">
+              <a:solidFill>
+                <a:srgbClr val="B0C4DE"/>
+              </a:solidFill>
+            </a:endParaRPr>
           </a:p>
         </p:txBody>
       </p:sp>
@@ -13027,12 +14788,140 @@
           <a:p>
             <a:pPr algn="l"/>
             <a:r>
-              <a:rPr sz="1000" b="0" i="0">
+              <a:rPr sz="1000" b="0" i="0" dirty="0">
                 <a:solidFill>
                   <a:srgbClr val="00D48A"/>
                 </a:solidFill>
               </a:rPr>
-              <a:t>✔  Python executa a ferramenta diretamente; LLM formata apenas a resposta ao cliente.</a:t>
+              <a:t>✔  Python </a:t>
+            </a:r>
+            <a:r>
+              <a:rPr sz="1000" b="0" i="0" dirty="0" err="1">
+                <a:solidFill>
+                  <a:srgbClr val="00D48A"/>
+                </a:solidFill>
+              </a:rPr>
+              <a:t>executa</a:t>
+            </a:r>
+            <a:r>
+              <a:rPr sz="1000" b="0" i="0" dirty="0">
+                <a:solidFill>
+                  <a:srgbClr val="00D48A"/>
+                </a:solidFill>
+              </a:rPr>
+              <a:t> a </a:t>
+            </a:r>
+            <a:r>
+              <a:rPr sz="1000" b="0" i="0" dirty="0" err="1">
+                <a:solidFill>
+                  <a:srgbClr val="00D48A"/>
+                </a:solidFill>
+              </a:rPr>
+              <a:t>ferramenta</a:t>
+            </a:r>
+            <a:r>
+              <a:rPr sz="1000" b="0" i="0" dirty="0">
+                <a:solidFill>
+                  <a:srgbClr val="00D48A"/>
+                </a:solidFill>
+              </a:rPr>
+              <a:t> </a:t>
+            </a:r>
+            <a:r>
+              <a:rPr sz="1000" b="0" i="0" dirty="0" err="1">
+                <a:solidFill>
+                  <a:srgbClr val="00D48A"/>
+                </a:solidFill>
+              </a:rPr>
+              <a:t>diretamente</a:t>
+            </a:r>
+            <a:r>
+              <a:rPr sz="1000" b="0" i="0" dirty="0">
+                <a:solidFill>
+                  <a:srgbClr val="00D48A"/>
+                </a:solidFill>
+              </a:rPr>
+              <a:t>; LLM </a:t>
+            </a:r>
+            <a:r>
+              <a:rPr sz="1000" b="0" i="0" dirty="0" err="1">
+                <a:solidFill>
+                  <a:srgbClr val="00D48A"/>
+                </a:solidFill>
+              </a:rPr>
+              <a:t>formata</a:t>
+            </a:r>
+            <a:r>
+              <a:rPr sz="1000" b="0" i="0" dirty="0">
+                <a:solidFill>
+                  <a:srgbClr val="00D48A"/>
+                </a:solidFill>
+              </a:rPr>
+              <a:t> </a:t>
+            </a:r>
+            <a:r>
+              <a:rPr sz="1000" b="0" i="0" dirty="0" err="1">
+                <a:solidFill>
+                  <a:srgbClr val="00D48A"/>
+                </a:solidFill>
+              </a:rPr>
+              <a:t>apenas</a:t>
+            </a:r>
+            <a:r>
+              <a:rPr sz="1000" b="0" i="0" dirty="0">
+                <a:solidFill>
+                  <a:srgbClr val="00D48A"/>
+                </a:solidFill>
+              </a:rPr>
+              <a:t> a </a:t>
+            </a:r>
+            <a:r>
+              <a:rPr sz="1000" b="0" i="0" dirty="0" err="1">
+                <a:solidFill>
+                  <a:srgbClr val="00D48A"/>
+                </a:solidFill>
+              </a:rPr>
+              <a:t>resposta</a:t>
+            </a:r>
+            <a:r>
+              <a:rPr sz="1000" b="0" i="0" dirty="0">
+                <a:solidFill>
+                  <a:srgbClr val="00D48A"/>
+                </a:solidFill>
+              </a:rPr>
+              <a:t> </a:t>
+            </a:r>
+            <a:r>
+              <a:rPr sz="1000" b="0" i="0" dirty="0" err="1">
+                <a:solidFill>
+                  <a:srgbClr val="00D48A"/>
+                </a:solidFill>
+              </a:rPr>
+              <a:t>ao</a:t>
+            </a:r>
+            <a:r>
+              <a:rPr sz="1000" b="0" i="0" dirty="0">
+                <a:solidFill>
+                  <a:srgbClr val="00D48A"/>
+                </a:solidFill>
+              </a:rPr>
+              <a:t> </a:t>
+            </a:r>
+            <a:r>
+              <a:rPr sz="1000" b="0" i="0" dirty="0" err="1">
+                <a:solidFill>
+                  <a:srgbClr val="00D48A"/>
+                </a:solidFill>
+              </a:rPr>
+              <a:t>cliente</a:t>
+            </a:r>
+            <a:r>
+              <a:rPr sz="1000" b="0" i="0" dirty="0">
+                <a:solidFill>
+                  <a:srgbClr val="00D48A"/>
+                </a:solidFill>
+              </a:rPr>
+              <a:t>.</a:t>
             </a:r>
           </a:p>
         </p:txBody>
@@ -14320,4 +16209,265 @@
   </a:objectDefaults>
   <a:extraClrSchemeLst/>
 </a:theme>
+</file>
+
+<file path=ppt/theme/theme2.xml><?xml version="1.0" encoding="utf-8"?>
+<a:theme xmlns:a="http://schemas.openxmlformats.org/drawingml/2006/main" name="Tema do Office">
+  <a:themeElements>
+    <a:clrScheme name="Escritório">
+      <a:dk1>
+        <a:sysClr val="windowText" lastClr="000000"/>
+      </a:dk1>
+      <a:lt1>
+        <a:sysClr val="window" lastClr="FFFFFF"/>
+      </a:lt1>
+      <a:dk2>
+        <a:srgbClr val="44546A"/>
+      </a:dk2>
+      <a:lt2>
+        <a:srgbClr val="E7E6E6"/>
+      </a:lt2>
+      <a:accent1>
+        <a:srgbClr val="5B9BD5"/>
+      </a:accent1>
+      <a:accent2>
+        <a:srgbClr val="ED7D31"/>
+      </a:accent2>
+      <a:accent3>
+        <a:srgbClr val="A5A5A5"/>
+      </a:accent3>
+      <a:accent4>
+        <a:srgbClr val="FFC000"/>
+      </a:accent4>
+      <a:accent5>
+        <a:srgbClr val="4472C4"/>
+      </a:accent5>
+      <a:accent6>
+        <a:srgbClr val="70AD47"/>
+      </a:accent6>
+      <a:hlink>
+        <a:srgbClr val="0563C1"/>
+      </a:hlink>
+      <a:folHlink>
+        <a:srgbClr val="954F72"/>
+      </a:folHlink>
+    </a:clrScheme>
+    <a:fontScheme name="Escritório">
+      <a:majorFont>
+        <a:latin typeface="Calibri Light" panose="020F0302020204030204"/>
+        <a:ea typeface=""/>
+        <a:cs typeface=""/>
+        <a:font script="Jpan" typeface="ＭＳ Ｐゴシック"/>
+        <a:font script="Hang" typeface="맑은 고딕"/>
+        <a:font script="Hans" typeface="宋体"/>
+        <a:font script="Hant" typeface="新細明體"/>
+        <a:font script="Arab" typeface="Times New Roman"/>
+        <a:font script="Hebr" typeface="Times New Roman"/>
+        <a:font script="Thai" typeface="Angsana New"/>
+        <a:font script="Ethi" typeface="Nyala"/>
+        <a:font script="Beng" typeface="Vrinda"/>
+        <a:font script="Gujr" typeface="Shruti"/>
+        <a:font script="Khmr" typeface="MoolBoran"/>
+        <a:font script="Knda" typeface="Tunga"/>
+        <a:font script="Guru" typeface="Raavi"/>
+        <a:font script="Cans" typeface="Euphemia"/>
+        <a:font script="Cher" typeface="Plantagenet Cherokee"/>
+        <a:font script="Yiii" typeface="Microsoft Yi Baiti"/>
+        <a:font script="Tibt" typeface="Microsoft Himalaya"/>
+        <a:font script="Thaa" typeface="MV Boli"/>
+        <a:font script="Deva" typeface="Mangal"/>
+        <a:font script="Telu" typeface="Gautami"/>
+        <a:font script="Taml" typeface="Latha"/>
+        <a:font script="Syrc" typeface="Estrangelo Edessa"/>
+        <a:font script="Orya" typeface="Kalinga"/>
+        <a:font script="Mlym" typeface="Kartika"/>
+        <a:font script="Laoo" typeface="DokChampa"/>
+        <a:font script="Sinh" typeface="Iskoola Pota"/>
+        <a:font script="Mong" typeface="Mongolian Baiti"/>
+        <a:font script="Viet" typeface="Times New Roman"/>
+        <a:font script="Uigh" typeface="Microsoft Uighur"/>
+        <a:font script="Geor" typeface="Sylfaen"/>
+      </a:majorFont>
+      <a:minorFont>
+        <a:latin typeface="Calibri" panose="020F0502020204030204"/>
+        <a:ea typeface=""/>
+        <a:cs typeface=""/>
+        <a:font script="Jpan" typeface="ＭＳ Ｐゴシック"/>
+        <a:font script="Hang" typeface="맑은 고딕"/>
+        <a:font script="Hans" typeface="宋体"/>
+        <a:font script="Hant" typeface="新細明體"/>
+        <a:font script="Arab" typeface="Arial"/>
+        <a:font script="Hebr" typeface="Arial"/>
+        <a:font script="Thai" typeface="Cordia New"/>
+        <a:font script="Ethi" typeface="Nyala"/>
+        <a:font script="Beng" typeface="Vrinda"/>
+        <a:font script="Gujr" typeface="Shruti"/>
+        <a:font script="Khmr" typeface="DaunPenh"/>
+        <a:font script="Knda" typeface="Tunga"/>
+        <a:font script="Guru" typeface="Raavi"/>
+        <a:font script="Cans" typeface="Euphemia"/>
+        <a:font script="Cher" typeface="Plantagenet Cherokee"/>
+        <a:font script="Yiii" typeface="Microsoft Yi Baiti"/>
+        <a:font script="Tibt" typeface="Microsoft Himalaya"/>
+        <a:font script="Thaa" typeface="MV Boli"/>
+        <a:font script="Deva" typeface="Mangal"/>
+        <a:font script="Telu" typeface="Gautami"/>
+        <a:font script="Taml" typeface="Latha"/>
+        <a:font script="Syrc" typeface="Estrangelo Edessa"/>
+        <a:font script="Orya" typeface="Kalinga"/>
+        <a:font script="Mlym" typeface="Kartika"/>
+        <a:font script="Laoo" typeface="DokChampa"/>
+        <a:font script="Sinh" typeface="Iskoola Pota"/>
+        <a:font script="Mong" typeface="Mongolian Baiti"/>
+        <a:font script="Viet" typeface="Arial"/>
+        <a:font script="Uigh" typeface="Microsoft Uighur"/>
+        <a:font script="Geor" typeface="Sylfaen"/>
+      </a:minorFont>
+    </a:fontScheme>
+    <a:fmtScheme name="Escritório">
+      <a:fillStyleLst>
+        <a:solidFill>
+          <a:schemeClr val="phClr"/>
+        </a:solidFill>
+        <a:gradFill rotWithShape="1">
+          <a:gsLst>
+            <a:gs pos="0">
+              <a:schemeClr val="phClr">
+                <a:lumMod val="110000"/>
+                <a:satMod val="105000"/>
+                <a:tint val="67000"/>
+              </a:schemeClr>
+            </a:gs>
+            <a:gs pos="50000">
+              <a:schemeClr val="phClr">
+                <a:lumMod val="105000"/>
+                <a:satMod val="103000"/>
+                <a:tint val="73000"/>
+              </a:schemeClr>
+            </a:gs>
+            <a:gs pos="100000">
+              <a:schemeClr val="phClr">
+                <a:lumMod val="105000"/>
+                <a:satMod val="109000"/>
+                <a:tint val="81000"/>
+              </a:schemeClr>
+            </a:gs>
+          </a:gsLst>
+          <a:lin ang="5400000" scaled="0"/>
+        </a:gradFill>
+        <a:gradFill rotWithShape="1">
+          <a:gsLst>
+            <a:gs pos="0">
+              <a:schemeClr val="phClr">
+                <a:satMod val="103000"/>
+                <a:lumMod val="102000"/>
+                <a:tint val="94000"/>
+              </a:schemeClr>
+            </a:gs>
+            <a:gs pos="50000">
+              <a:schemeClr val="phClr">
+                <a:satMod val="110000"/>
+                <a:lumMod val="100000"/>
+                <a:shade val="100000"/>
+              </a:schemeClr>
+            </a:gs>
+            <a:gs pos="100000">
+              <a:schemeClr val="phClr">
+                <a:lumMod val="99000"/>
+                <a:satMod val="120000"/>
+                <a:shade val="78000"/>
+              </a:schemeClr>
+            </a:gs>
+          </a:gsLst>
+          <a:lin ang="5400000" scaled="0"/>
+        </a:gradFill>
+      </a:fillStyleLst>
+      <a:lnStyleLst>
+        <a:ln w="6350" cap="flat" cmpd="sng" algn="ctr">
+          <a:solidFill>
+            <a:schemeClr val="phClr"/>
+          </a:solidFill>
+          <a:prstDash val="solid"/>
+          <a:miter lim="800000"/>
+        </a:ln>
+        <a:ln w="12700" cap="flat" cmpd="sng" algn="ctr">
+          <a:solidFill>
+            <a:schemeClr val="phClr"/>
+          </a:solidFill>
+          <a:prstDash val="solid"/>
+          <a:miter lim="800000"/>
+        </a:ln>
+        <a:ln w="19050" cap="flat" cmpd="sng" algn="ctr">
+          <a:solidFill>
+            <a:schemeClr val="phClr"/>
+          </a:solidFill>
+          <a:prstDash val="solid"/>
+          <a:miter lim="800000"/>
+        </a:ln>
+      </a:lnStyleLst>
+      <a:effectStyleLst>
+        <a:effectStyle>
+          <a:effectLst/>
+        </a:effectStyle>
+        <a:effectStyle>
+          <a:effectLst/>
+        </a:effectStyle>
+        <a:effectStyle>
+          <a:effectLst>
+            <a:outerShdw blurRad="57150" dist="19050" dir="5400000" algn="ctr" rotWithShape="0">
+              <a:srgbClr val="000000">
+                <a:alpha val="63000"/>
+              </a:srgbClr>
+            </a:outerShdw>
+          </a:effectLst>
+        </a:effectStyle>
+      </a:effectStyleLst>
+      <a:bgFillStyleLst>
+        <a:solidFill>
+          <a:schemeClr val="phClr"/>
+        </a:solidFill>
+        <a:solidFill>
+          <a:schemeClr val="phClr">
+            <a:tint val="95000"/>
+            <a:satMod val="170000"/>
+          </a:schemeClr>
+        </a:solidFill>
+        <a:gradFill rotWithShape="1">
+          <a:gsLst>
+            <a:gs pos="0">
+              <a:schemeClr val="phClr">
+                <a:tint val="93000"/>
+                <a:satMod val="150000"/>
+                <a:shade val="98000"/>
+                <a:lumMod val="102000"/>
+              </a:schemeClr>
+            </a:gs>
+            <a:gs pos="50000">
+              <a:schemeClr val="phClr">
+                <a:tint val="98000"/>
+                <a:satMod val="130000"/>
+                <a:shade val="90000"/>
+                <a:lumMod val="103000"/>
+              </a:schemeClr>
+            </a:gs>
+            <a:gs pos="100000">
+              <a:schemeClr val="phClr">
+                <a:shade val="63000"/>
+                <a:satMod val="120000"/>
+              </a:schemeClr>
+            </a:gs>
+          </a:gsLst>
+          <a:lin ang="5400000" scaled="0"/>
+        </a:gradFill>
+      </a:bgFillStyleLst>
+    </a:fmtScheme>
+  </a:themeElements>
+  <a:objectDefaults/>
+  <a:extraClrSchemeLst/>
+  <a:extLst>
+    <a:ext uri="{05A4C25C-085E-4340-85A3-A5531E510DB2}">
+      <thm15:themeFamily xmlns:thm15="http://schemas.microsoft.com/office/thememl/2012/main" name="Office Theme" id="{62F939B6-93AF-4DB8-9C6B-D6C7DFDC589F}" vid="{4A3C46E8-61CC-4603-A589-7422A47A8E4A}"/>
+    </a:ext>
+  </a:extLst>
+</a:theme>
 </file>
</xml_diff>